<commit_message>
Atualiza link do repositório e registro de contribuições
- link real do GitHub no README, planejamento, relatório e slides
- divisão de contribuições e roteiro da apresentação revisados
- relatório técnico e apresentação regenerados
</commit_message>
<xml_diff>
--- a/docs/entrega/apresentacao.pptx
+++ b/docs/entrega/apresentacao.pptx
@@ -1153,7 +1153,7 @@
           <a:lstStyle/>
           <a:p>
             <a:r>
-              <a:t>PEDRO: Demonstração ao vivo. (1) Validar BRA2E19 em 'Identificar automaticamente'. (2) Validar (23) 91234-5678 e ler a mensagem. (3) Processar planilha &gt; Usar arquivo de exemplo; baixar o relatório. (4) Expressões e AFNε &gt; ER-02 &gt; simular BRA-2E19 e mostrar o conjunto vazio no passo 6. Se o professor pedir outra entrada, digitar na página inicial.</a:t>
+              <a:t>YURI: Demonstração ao vivo. (1) Validar BRA2E19 em 'Identificar automaticamente'. (2) Validar (23) 91234-5678 e ler a mensagem. (3) Processar planilha &gt; Usar arquivo de exemplo; baixar o relatório. (4) Expressões e AFNε &gt; ER-02 &gt; simular BRA-2E19 e mostrar o conjunto vazio no passo 6. Se o professor pedir outra entrada, digitar na página inicial.</a:t>
             </a:r>
           </a:p>
         </p:txBody>
@@ -1433,7 +1433,7 @@
           <a:lstStyle/>
           <a:p>
             <a:r>
-              <a:t>JOÃO: Apresentar a contribuição de cada integrante (ajustar se a divisão real for diferente) e a declaração de uso de IA exigida pelo professor.</a:t>
+              <a:t>YURI: Apresentar a contribuição de cada integrante e a declaração de uso de IA exigida pelo professor.</a:t>
             </a:r>
           </a:p>
         </p:txBody>
@@ -5146,7 +5146,7 @@
                 </a:solidFill>
                 <a:latin typeface="Calibri"/>
               </a:rPr>
-              <a:t>Pedro Paulo  ·  Yuri Aguiar  ·  João Rath</a:t>
+              <a:t>Yuri Aguiar  ·  Pedro Paulo  ·  João Rath</a:t>
             </a:r>
           </a:p>
           <a:p>
@@ -18056,7 +18056,7 @@
                 </a:solidFill>
                 <a:latin typeface="Calibri"/>
               </a:rPr>
-              <a:t>PP</a:t>
+              <a:t>YA</a:t>
             </a:r>
           </a:p>
         </p:txBody>
@@ -18091,7 +18091,7 @@
                 </a:solidFill>
                 <a:latin typeface="Cambria"/>
               </a:rPr>
-              <a:t>Pedro Paulo</a:t>
+              <a:t>Yuri Aguiar</a:t>
             </a:r>
           </a:p>
         </p:txBody>
@@ -18104,8 +18104,8 @@
         </p:nvSpPr>
         <p:spPr>
           <a:xfrm>
-            <a:off x="822959" y="2651760"/>
-            <a:ext cx="3017520" cy="1097280"/>
+            <a:off x="822959" y="2606040"/>
+            <a:ext cx="3017520" cy="1188720"/>
           </a:xfrm>
           <a:prstGeom prst="rect">
             <a:avLst/>
@@ -18120,13 +18120,13 @@
           <a:p>
             <a:pPr algn="l"/>
             <a:r>
-              <a:rPr sz="1500" b="0" i="0">
+              <a:rPr sz="1400" b="0" i="0">
                 <a:solidFill>
                   <a:srgbClr val="1F2933"/>
                 </a:solidFill>
                 <a:latin typeface="Calibri"/>
               </a:rPr>
-              <a:t>Interface web, processamento de CSV, dados de exemplo</a:t>
+              <a:t>Arquitetura, as 5 ERs, AFNε (Thompson), validador, CSV, interface web, testes automatizados, documentação</a:t>
             </a:r>
           </a:p>
         </p:txBody>
@@ -18161,7 +18161,7 @@
                 </a:solidFill>
                 <a:latin typeface="Calibri"/>
               </a:rPr>
-              <a:t>ER-01 · ER-02 · demonstração</a:t>
+              <a:t>Thompson · ER-03 · demonstração</a:t>
             </a:r>
           </a:p>
         </p:txBody>
@@ -18288,7 +18288,7 @@
                 </a:solidFill>
                 <a:latin typeface="Calibri"/>
               </a:rPr>
-              <a:t>YA</a:t>
+              <a:t>PP</a:t>
             </a:r>
           </a:p>
         </p:txBody>
@@ -18323,7 +18323,7 @@
                 </a:solidFill>
                 <a:latin typeface="Cambria"/>
               </a:rPr>
-              <a:t>Yuri Aguiar</a:t>
+              <a:t>Pedro Paulo</a:t>
             </a:r>
           </a:p>
         </p:txBody>
@@ -18336,8 +18336,8 @@
         </p:nvSpPr>
         <p:spPr>
           <a:xfrm>
-            <a:off x="4571999" y="2651760"/>
-            <a:ext cx="3017520" cy="1097280"/>
+            <a:off x="4571999" y="2606040"/>
+            <a:ext cx="3017520" cy="1188720"/>
           </a:xfrm>
           <a:prstGeom prst="rect">
             <a:avLst/>
@@ -18352,13 +18352,13 @@
           <a:p>
             <a:pPr algn="l"/>
             <a:r>
-              <a:rPr sz="1500" b="0" i="0">
+              <a:rPr sz="1400" b="0" i="0">
                 <a:solidFill>
                   <a:srgbClr val="1F2933"/>
                 </a:solidFill>
                 <a:latin typeface="Calibri"/>
               </a:rPr>
-              <a:t>Construção e simulação do AFNε, diagramas, repositório</a:t>
+              <a:t>Dados de exemplo, casos de teste das ER-01 e ER-02, revisão da interface</a:t>
             </a:r>
           </a:p>
         </p:txBody>
@@ -18393,7 +18393,7 @@
                 </a:solidFill>
                 <a:latin typeface="Calibri"/>
               </a:rPr>
-              <a:t>ER-03 · Thompson</a:t>
+              <a:t>ER-01 · ER-02</a:t>
             </a:r>
           </a:p>
         </p:txBody>
@@ -18568,8 +18568,8 @@
         </p:nvSpPr>
         <p:spPr>
           <a:xfrm>
-            <a:off x="8321040" y="2651760"/>
-            <a:ext cx="3017520" cy="1097280"/>
+            <a:off x="8321040" y="2606040"/>
+            <a:ext cx="3017520" cy="1188720"/>
           </a:xfrm>
           <a:prstGeom prst="rect">
             <a:avLst/>
@@ -18584,13 +18584,13 @@
           <a:p>
             <a:pPr algn="l"/>
             <a:r>
-              <a:rPr sz="1500" b="0" i="0">
+              <a:rPr sz="1400" b="0" i="0">
                 <a:solidFill>
                   <a:srgbClr val="1F2933"/>
                 </a:solidFill>
                 <a:latin typeface="Calibri"/>
               </a:rPr>
-              <a:t>Casos de teste, testes automatizados, análise, relatório</a:t>
+              <a:t>Casos de teste das ER-04 e ER-05, revisão da notação formal e do relatório</a:t>
             </a:r>
           </a:p>
         </p:txBody>
@@ -18719,7 +18719,7 @@
                 </a:solidFill>
                 <a:latin typeface="Calibri"/>
               </a:rPr>
-              <a:t>definição do problema, escolha das ERs, notação formal e revisão dos AFNε.</a:t>
+              <a:t>definição do problema, escolha das ERs e revisão dos AFNε.</a:t>
             </a:r>
           </a:p>
           <a:p>
@@ -18879,7 +18879,7 @@
                 </a:solidFill>
                 <a:latin typeface="Calibri"/>
               </a:rPr>
-              <a:t>Repositório: github.com/&lt;usuario&gt;/validafrete</a:t>
+              <a:t>Repositório: github.com/yuriaguiardev/valida-frete</a:t>
             </a:r>
           </a:p>
           <a:p>
@@ -18895,7 +18895,7 @@
                 </a:solidFill>
                 <a:latin typeface="Calibri"/>
               </a:rPr>
-              <a:t>Pedro Paulo · Yuri Aguiar · João Rath — CC6NA</a:t>
+              <a:t>Yuri Aguiar · Pedro Paulo · João Rath — CC6NA</a:t>
             </a:r>
           </a:p>
         </p:txBody>

</xml_diff>

<commit_message>
Mantém o roteiro da apresentação fora do repositório
- remove o roteiro de fala e a divisão de falas do CONTRIBUICOES.md e do relatório
- apresentação versionada sem notas do orador
- pasta roteiro/ adicionada ao .gitignore
</commit_message>
<xml_diff>
--- a/docs/entrega/apresentacao.pptx
+++ b/docs/entrega/apresentacao.pptx
@@ -6,27 +6,27 @@
   </p:sldMasterIdLst>
   <p:sldIdLst>
     <p:sldId id="256" r:id="rId7"/>
-    <p:sldId id="257" r:id="rId9"/>
-    <p:sldId id="258" r:id="rId10"/>
-    <p:sldId id="259" r:id="rId11"/>
-    <p:sldId id="260" r:id="rId12"/>
-    <p:sldId id="261" r:id="rId13"/>
-    <p:sldId id="262" r:id="rId14"/>
-    <p:sldId id="263" r:id="rId15"/>
-    <p:sldId id="264" r:id="rId16"/>
-    <p:sldId id="265" r:id="rId17"/>
-    <p:sldId id="266" r:id="rId18"/>
-    <p:sldId id="267" r:id="rId19"/>
-    <p:sldId id="268" r:id="rId20"/>
-    <p:sldId id="269" r:id="rId21"/>
-    <p:sldId id="270" r:id="rId22"/>
-    <p:sldId id="271" r:id="rId23"/>
-    <p:sldId id="272" r:id="rId24"/>
-    <p:sldId id="273" r:id="rId25"/>
-    <p:sldId id="274" r:id="rId26"/>
-    <p:sldId id="275" r:id="rId27"/>
-    <p:sldId id="276" r:id="rId28"/>
-    <p:sldId id="277" r:id="rId29"/>
+    <p:sldId id="257" r:id="rId8"/>
+    <p:sldId id="258" r:id="rId9"/>
+    <p:sldId id="259" r:id="rId10"/>
+    <p:sldId id="260" r:id="rId11"/>
+    <p:sldId id="261" r:id="rId12"/>
+    <p:sldId id="262" r:id="rId13"/>
+    <p:sldId id="263" r:id="rId14"/>
+    <p:sldId id="264" r:id="rId15"/>
+    <p:sldId id="265" r:id="rId16"/>
+    <p:sldId id="266" r:id="rId17"/>
+    <p:sldId id="267" r:id="rId18"/>
+    <p:sldId id="268" r:id="rId19"/>
+    <p:sldId id="269" r:id="rId20"/>
+    <p:sldId id="270" r:id="rId21"/>
+    <p:sldId id="271" r:id="rId22"/>
+    <p:sldId id="272" r:id="rId23"/>
+    <p:sldId id="273" r:id="rId24"/>
+    <p:sldId id="274" r:id="rId25"/>
+    <p:sldId id="275" r:id="rId26"/>
+    <p:sldId id="276" r:id="rId27"/>
+    <p:sldId id="277" r:id="rId28"/>
   </p:sldIdLst>
   <p:sldSz cx="12191695" cy="6858000" type="screen4x3"/>
   <p:notesSz cx="6858000" cy="9144000"/>
@@ -126,1896 +126,6 @@
     </a:lvl9pPr>
   </p:defaultTextStyle>
 </p:presentation>
-</file>
-
-<file path=ppt/notesMasters/notesMaster1.xml><?xml version="1.0" encoding="utf-8"?>
-<p:notesMaster xmlns:a="http://schemas.openxmlformats.org/drawingml/2006/main" xmlns:p="http://schemas.openxmlformats.org/presentationml/2006/main" xmlns:r="http://schemas.openxmlformats.org/officeDocument/2006/relationships">
-  <p:cSld>
-    <p:bg>
-      <p:bgRef idx="1001">
-        <a:schemeClr val="bg1"/>
-      </p:bgRef>
-    </p:bg>
-    <p:spTree>
-      <p:nvGrpSpPr>
-        <p:cNvPr id="1" name=""/>
-        <p:cNvGrpSpPr/>
-        <p:nvPr/>
-      </p:nvGrpSpPr>
-      <p:grpSpPr>
-        <a:xfrm>
-          <a:off x="0" y="0"/>
-          <a:ext cx="0" cy="0"/>
-          <a:chOff x="0" y="0"/>
-          <a:chExt cx="0" cy="0"/>
-        </a:xfrm>
-      </p:grpSpPr>
-      <p:sp>
-        <p:nvSpPr>
-          <p:cNvPr id="2" name="Header Placeholder 1"/>
-          <p:cNvSpPr>
-            <a:spLocks noGrp="1"/>
-          </p:cNvSpPr>
-          <p:nvPr>
-            <p:ph type="hdr" sz="quarter"/>
-          </p:nvPr>
-        </p:nvSpPr>
-        <p:spPr>
-          <a:xfrm>
-            <a:off x="0" y="0"/>
-            <a:ext cx="2971800" cy="457200"/>
-          </a:xfrm>
-          <a:prstGeom prst="rect">
-            <a:avLst/>
-          </a:prstGeom>
-        </p:spPr>
-        <p:txBody>
-          <a:bodyPr vert="horz" lIns="91440" tIns="45720" rIns="91440" bIns="45720" rtlCol="0"/>
-          <a:lstStyle>
-            <a:lvl1pPr algn="l">
-              <a:defRPr sz="1200"/>
-            </a:lvl1pPr>
-          </a:lstStyle>
-          <a:p>
-            <a:endParaRPr lang="en-US"/>
-          </a:p>
-        </p:txBody>
-      </p:sp>
-      <p:sp>
-        <p:nvSpPr>
-          <p:cNvPr id="3" name="Date Placeholder 2"/>
-          <p:cNvSpPr>
-            <a:spLocks noGrp="1"/>
-          </p:cNvSpPr>
-          <p:nvPr>
-            <p:ph type="dt" idx="1"/>
-          </p:nvPr>
-        </p:nvSpPr>
-        <p:spPr>
-          <a:xfrm>
-            <a:off x="3884613" y="0"/>
-            <a:ext cx="2971800" cy="457200"/>
-          </a:xfrm>
-          <a:prstGeom prst="rect">
-            <a:avLst/>
-          </a:prstGeom>
-        </p:spPr>
-        <p:txBody>
-          <a:bodyPr vert="horz" lIns="91440" tIns="45720" rIns="91440" bIns="45720" rtlCol="0"/>
-          <a:lstStyle>
-            <a:lvl1pPr algn="r">
-              <a:defRPr sz="1200"/>
-            </a:lvl1pPr>
-          </a:lstStyle>
-          <a:p>
-            <a:fld id="{0F89C1C7-3DCD-1040-A9CF-14679D8B5DDD}" type="datetimeFigureOut">
-              <a:rPr lang="en-US" smtClean="0"/>
-              <a:t>10/17/16</a:t>
-            </a:fld>
-            <a:endParaRPr lang="en-US"/>
-          </a:p>
-        </p:txBody>
-      </p:sp>
-      <p:sp>
-        <p:nvSpPr>
-          <p:cNvPr id="4" name="Slide Image Placeholder 3"/>
-          <p:cNvSpPr>
-            <a:spLocks noGrp="1" noRot="1" noChangeAspect="1"/>
-          </p:cNvSpPr>
-          <p:nvPr>
-            <p:ph type="sldImg" idx="2"/>
-          </p:nvPr>
-        </p:nvSpPr>
-        <p:spPr>
-          <a:xfrm>
-            <a:off x="1143000" y="685800"/>
-            <a:ext cx="4572000" cy="3429000"/>
-          </a:xfrm>
-          <a:prstGeom prst="rect">
-            <a:avLst/>
-          </a:prstGeom>
-          <a:noFill/>
-          <a:ln w="12700">
-            <a:solidFill>
-              <a:prstClr val="black"/>
-            </a:solidFill>
-          </a:ln>
-        </p:spPr>
-        <p:txBody>
-          <a:bodyPr vert="horz" lIns="91440" tIns="45720" rIns="91440" bIns="45720" rtlCol="0" anchor="ctr"/>
-          <a:lstStyle/>
-          <a:p>
-            <a:endParaRPr lang="en-US"/>
-          </a:p>
-        </p:txBody>
-      </p:sp>
-      <p:sp>
-        <p:nvSpPr>
-          <p:cNvPr id="5" name="Notes Placeholder 4"/>
-          <p:cNvSpPr>
-            <a:spLocks noGrp="1"/>
-          </p:cNvSpPr>
-          <p:nvPr>
-            <p:ph type="body" sz="quarter" idx="3"/>
-          </p:nvPr>
-        </p:nvSpPr>
-        <p:spPr>
-          <a:xfrm>
-            <a:off x="685800" y="4343400"/>
-            <a:ext cx="5486400" cy="4114800"/>
-          </a:xfrm>
-          <a:prstGeom prst="rect">
-            <a:avLst/>
-          </a:prstGeom>
-        </p:spPr>
-        <p:txBody>
-          <a:bodyPr vert="horz" lIns="91440" tIns="45720" rIns="91440" bIns="45720" rtlCol="0"/>
-          <a:lstStyle/>
-          <a:p>
-            <a:pPr lvl="0"/>
-            <a:r>
-              <a:rPr lang="en-US" smtClean="0"/>
-              <a:t>Click to edit Master text styles</a:t>
-            </a:r>
-          </a:p>
-          <a:p>
-            <a:pPr lvl="1"/>
-            <a:r>
-              <a:rPr lang="en-US" smtClean="0"/>
-              <a:t>Second level</a:t>
-            </a:r>
-          </a:p>
-          <a:p>
-            <a:pPr lvl="2"/>
-            <a:r>
-              <a:rPr lang="en-US" smtClean="0"/>
-              <a:t>Third level</a:t>
-            </a:r>
-          </a:p>
-          <a:p>
-            <a:pPr lvl="3"/>
-            <a:r>
-              <a:rPr lang="en-US" smtClean="0"/>
-              <a:t>Fourth level</a:t>
-            </a:r>
-          </a:p>
-          <a:p>
-            <a:pPr lvl="4"/>
-            <a:r>
-              <a:rPr lang="en-US" smtClean="0"/>
-              <a:t>Fifth level</a:t>
-            </a:r>
-            <a:endParaRPr lang="en-US"/>
-          </a:p>
-        </p:txBody>
-      </p:sp>
-      <p:sp>
-        <p:nvSpPr>
-          <p:cNvPr id="6" name="Footer Placeholder 5"/>
-          <p:cNvSpPr>
-            <a:spLocks noGrp="1"/>
-          </p:cNvSpPr>
-          <p:nvPr>
-            <p:ph type="ftr" sz="quarter" idx="4"/>
-          </p:nvPr>
-        </p:nvSpPr>
-        <p:spPr>
-          <a:xfrm>
-            <a:off x="0" y="8685213"/>
-            <a:ext cx="2971800" cy="457200"/>
-          </a:xfrm>
-          <a:prstGeom prst="rect">
-            <a:avLst/>
-          </a:prstGeom>
-        </p:spPr>
-        <p:txBody>
-          <a:bodyPr vert="horz" lIns="91440" tIns="45720" rIns="91440" bIns="45720" rtlCol="0" anchor="b"/>
-          <a:lstStyle>
-            <a:lvl1pPr algn="l">
-              <a:defRPr sz="1200"/>
-            </a:lvl1pPr>
-          </a:lstStyle>
-          <a:p>
-            <a:endParaRPr lang="en-US"/>
-          </a:p>
-        </p:txBody>
-      </p:sp>
-      <p:sp>
-        <p:nvSpPr>
-          <p:cNvPr id="7" name="Slide Number Placeholder 6"/>
-          <p:cNvSpPr>
-            <a:spLocks noGrp="1"/>
-          </p:cNvSpPr>
-          <p:nvPr>
-            <p:ph type="sldNum" sz="quarter" idx="5"/>
-          </p:nvPr>
-        </p:nvSpPr>
-        <p:spPr>
-          <a:xfrm>
-            <a:off x="3884613" y="8685213"/>
-            <a:ext cx="2971800" cy="457200"/>
-          </a:xfrm>
-          <a:prstGeom prst="rect">
-            <a:avLst/>
-          </a:prstGeom>
-        </p:spPr>
-        <p:txBody>
-          <a:bodyPr vert="horz" lIns="91440" tIns="45720" rIns="91440" bIns="45720" rtlCol="0" anchor="b"/>
-          <a:lstStyle>
-            <a:lvl1pPr algn="r">
-              <a:defRPr sz="1200"/>
-            </a:lvl1pPr>
-          </a:lstStyle>
-          <a:p>
-            <a:fld id="{BB5E49A5-4136-284D-997B-48E1D791AD67}" type="slidenum">
-              <a:rPr lang="en-US" smtClean="0"/>
-              <a:t>‹#›</a:t>
-            </a:fld>
-            <a:endParaRPr lang="en-US"/>
-          </a:p>
-        </p:txBody>
-      </p:sp>
-    </p:spTree>
-    <p:extLst>
-      <p:ext uri="{BB962C8B-B14F-4D97-AF65-F5344CB8AC3E}">
-        <p14:creationId xmlns:p14="http://schemas.microsoft.com/office/powerpoint/2010/main" val="2623252185"/>
-      </p:ext>
-    </p:extLst>
-  </p:cSld>
-  <p:clrMap bg1="lt1" tx1="dk1" bg2="lt2" tx2="dk2" accent1="accent1" accent2="accent2" accent3="accent3" accent4="accent4" accent5="accent5" accent6="accent6" hlink="hlink" folHlink="folHlink"/>
-  <p:notesStyle>
-    <a:lvl1pPr marL="0" algn="l" defTabSz="457200" rtl="0" eaLnBrk="1" latinLnBrk="0" hangingPunct="1">
-      <a:defRPr sz="1200" kern="1200">
-        <a:solidFill>
-          <a:schemeClr val="tx1"/>
-        </a:solidFill>
-        <a:latin typeface="+mn-lt"/>
-        <a:ea typeface="+mn-ea"/>
-        <a:cs typeface="+mn-cs"/>
-      </a:defRPr>
-    </a:lvl1pPr>
-    <a:lvl2pPr marL="457200" algn="l" defTabSz="457200" rtl="0" eaLnBrk="1" latinLnBrk="0" hangingPunct="1">
-      <a:defRPr sz="1200" kern="1200">
-        <a:solidFill>
-          <a:schemeClr val="tx1"/>
-        </a:solidFill>
-        <a:latin typeface="+mn-lt"/>
-        <a:ea typeface="+mn-ea"/>
-        <a:cs typeface="+mn-cs"/>
-      </a:defRPr>
-    </a:lvl2pPr>
-    <a:lvl3pPr marL="914400" algn="l" defTabSz="457200" rtl="0" eaLnBrk="1" latinLnBrk="0" hangingPunct="1">
-      <a:defRPr sz="1200" kern="1200">
-        <a:solidFill>
-          <a:schemeClr val="tx1"/>
-        </a:solidFill>
-        <a:latin typeface="+mn-lt"/>
-        <a:ea typeface="+mn-ea"/>
-        <a:cs typeface="+mn-cs"/>
-      </a:defRPr>
-    </a:lvl3pPr>
-    <a:lvl4pPr marL="1371600" algn="l" defTabSz="457200" rtl="0" eaLnBrk="1" latinLnBrk="0" hangingPunct="1">
-      <a:defRPr sz="1200" kern="1200">
-        <a:solidFill>
-          <a:schemeClr val="tx1"/>
-        </a:solidFill>
-        <a:latin typeface="+mn-lt"/>
-        <a:ea typeface="+mn-ea"/>
-        <a:cs typeface="+mn-cs"/>
-      </a:defRPr>
-    </a:lvl4pPr>
-    <a:lvl5pPr marL="1828800" algn="l" defTabSz="457200" rtl="0" eaLnBrk="1" latinLnBrk="0" hangingPunct="1">
-      <a:defRPr sz="1200" kern="1200">
-        <a:solidFill>
-          <a:schemeClr val="tx1"/>
-        </a:solidFill>
-        <a:latin typeface="+mn-lt"/>
-        <a:ea typeface="+mn-ea"/>
-        <a:cs typeface="+mn-cs"/>
-      </a:defRPr>
-    </a:lvl5pPr>
-    <a:lvl6pPr marL="2286000" algn="l" defTabSz="457200" rtl="0" eaLnBrk="1" latinLnBrk="0" hangingPunct="1">
-      <a:defRPr sz="1200" kern="1200">
-        <a:solidFill>
-          <a:schemeClr val="tx1"/>
-        </a:solidFill>
-        <a:latin typeface="+mn-lt"/>
-        <a:ea typeface="+mn-ea"/>
-        <a:cs typeface="+mn-cs"/>
-      </a:defRPr>
-    </a:lvl6pPr>
-    <a:lvl7pPr marL="2743200" algn="l" defTabSz="457200" rtl="0" eaLnBrk="1" latinLnBrk="0" hangingPunct="1">
-      <a:defRPr sz="1200" kern="1200">
-        <a:solidFill>
-          <a:schemeClr val="tx1"/>
-        </a:solidFill>
-        <a:latin typeface="+mn-lt"/>
-        <a:ea typeface="+mn-ea"/>
-        <a:cs typeface="+mn-cs"/>
-      </a:defRPr>
-    </a:lvl7pPr>
-    <a:lvl8pPr marL="3200400" algn="l" defTabSz="457200" rtl="0" eaLnBrk="1" latinLnBrk="0" hangingPunct="1">
-      <a:defRPr sz="1200" kern="1200">
-        <a:solidFill>
-          <a:schemeClr val="tx1"/>
-        </a:solidFill>
-        <a:latin typeface="+mn-lt"/>
-        <a:ea typeface="+mn-ea"/>
-        <a:cs typeface="+mn-cs"/>
-      </a:defRPr>
-    </a:lvl8pPr>
-    <a:lvl9pPr marL="3657600" algn="l" defTabSz="457200" rtl="0" eaLnBrk="1" latinLnBrk="0" hangingPunct="1">
-      <a:defRPr sz="1200" kern="1200">
-        <a:solidFill>
-          <a:schemeClr val="tx1"/>
-        </a:solidFill>
-        <a:latin typeface="+mn-lt"/>
-        <a:ea typeface="+mn-ea"/>
-        <a:cs typeface="+mn-cs"/>
-      </a:defRPr>
-    </a:lvl9pPr>
-  </p:notesStyle>
-</p:notesMaster>
-</file>
-
-<file path=ppt/notesSlides/notesSlide1.xml><?xml version="1.0" encoding="utf-8"?>
-<p:notes xmlns:a="http://schemas.openxmlformats.org/drawingml/2006/main" xmlns:p="http://schemas.openxmlformats.org/presentationml/2006/main" xmlns:r="http://schemas.openxmlformats.org/officeDocument/2006/relationships">
-  <p:cSld>
-    <p:spTree>
-      <p:nvGrpSpPr>
-        <p:cNvPr id="1" name=""/>
-        <p:cNvGrpSpPr/>
-        <p:nvPr/>
-      </p:nvGrpSpPr>
-      <p:grpSpPr>
-        <a:xfrm>
-          <a:off x="0" y="0"/>
-          <a:ext cx="0" cy="0"/>
-          <a:chOff x="0" y="0"/>
-          <a:chExt cx="0" cy="0"/>
-        </a:xfrm>
-      </p:grpSpPr>
-      <p:sp>
-        <p:nvSpPr>
-          <p:cNvPr id="2" name="Slide Image Placeholder 1"/>
-          <p:cNvSpPr>
-            <a:spLocks noGrp="1"/>
-          </p:cNvSpPr>
-          <p:nvPr>
-            <p:ph type="sldImg" idx="2"/>
-          </p:nvPr>
-        </p:nvSpPr>
-        <p:spPr/>
-      </p:sp>
-      <p:sp>
-        <p:nvSpPr>
-          <p:cNvPr id="3" name="Notes Placeholder 2"/>
-          <p:cNvSpPr>
-            <a:spLocks noGrp="1"/>
-          </p:cNvSpPr>
-          <p:nvPr>
-            <p:ph type="body" idx="3" sz="quarter"/>
-          </p:nvPr>
-        </p:nvSpPr>
-        <p:spPr/>
-        <p:txBody>
-          <a:bodyPr/>
-          <a:lstStyle/>
-          <a:p>
-            <a:r>
-              <a:t>YURI: Apresentar a equipe e o tema. O ValidaFrete valida cadastros de fretes usando cinco Expressões Regulares e mostra, com o AFNε, onde cada valor falhou.</a:t>
-            </a:r>
-          </a:p>
-        </p:txBody>
-      </p:sp>
-      <p:sp>
-        <p:nvSpPr>
-          <p:cNvPr id="4" name="Slide Number Placeholder 3"/>
-          <p:cNvSpPr>
-            <a:spLocks noGrp="1"/>
-          </p:cNvSpPr>
-          <p:nvPr>
-            <p:ph type="sldNum" idx="5" sz="quarter"/>
-          </p:nvPr>
-        </p:nvSpPr>
-        <p:spPr/>
-      </p:sp>
-    </p:spTree>
-  </p:cSld>
-  <p:clrMapOvr>
-    <a:masterClrMapping/>
-  </p:clrMapOvr>
-</p:notes>
-</file>
-
-<file path=ppt/notesSlides/notesSlide10.xml><?xml version="1.0" encoding="utf-8"?>
-<p:notes xmlns:a="http://schemas.openxmlformats.org/drawingml/2006/main" xmlns:p="http://schemas.openxmlformats.org/presentationml/2006/main" xmlns:r="http://schemas.openxmlformats.org/officeDocument/2006/relationships">
-  <p:cSld>
-    <p:spTree>
-      <p:nvGrpSpPr>
-        <p:cNvPr id="1" name=""/>
-        <p:cNvGrpSpPr/>
-        <p:nvPr/>
-      </p:nvGrpSpPr>
-      <p:grpSpPr>
-        <a:xfrm>
-          <a:off x="0" y="0"/>
-          <a:ext cx="0" cy="0"/>
-          <a:chOff x="0" y="0"/>
-          <a:chExt cx="0" cy="0"/>
-        </a:xfrm>
-      </p:grpSpPr>
-      <p:sp>
-        <p:nvSpPr>
-          <p:cNvPr id="2" name="Slide Image Placeholder 1"/>
-          <p:cNvSpPr>
-            <a:spLocks noGrp="1"/>
-          </p:cNvSpPr>
-          <p:nvPr>
-            <p:ph type="sldImg" idx="2"/>
-          </p:nvPr>
-        </p:nvSpPr>
-        <p:spPr/>
-      </p:sp>
-      <p:sp>
-        <p:nvSpPr>
-          <p:cNvPr id="3" name="Notes Placeholder 2"/>
-          <p:cNvSpPr>
-            <a:spLocks noGrp="1"/>
-          </p:cNvSpPr>
-          <p:nvPr>
-            <p:ph type="body" idx="3" sz="quarter"/>
-          </p:nvPr>
-        </p:nvSpPr>
-        <p:spPr/>
-        <p:txBody>
-          <a:bodyPr/>
-          <a:lstStyle/>
-          <a:p>
-            <a:r>
-              <a:t>YURI: Ler a finalidade: Validar o telefone de contato do motorista. Exige um DDD realmente em uso no Brasil (67 códigos da Anatel), aceita o prefixo +55 e o DDD com ou sem parênteses — sempre balanceados — e distingue celular (9 + 8 dígitos) de fixo (2 a 5 + 7 dígitos). Mostrar que cada atalho da sintaxe do código corresponde a um operador formal (tabela de equivalência). re.fullmatch exige que a cadeia inteira pertença à linguagem, como as âncoras ^ e $.</a:t>
-            </a:r>
-          </a:p>
-        </p:txBody>
-      </p:sp>
-      <p:sp>
-        <p:nvSpPr>
-          <p:cNvPr id="4" name="Slide Number Placeholder 3"/>
-          <p:cNvSpPr>
-            <a:spLocks noGrp="1"/>
-          </p:cNvSpPr>
-          <p:nvPr>
-            <p:ph type="sldNum" idx="5" sz="quarter"/>
-          </p:nvPr>
-        </p:nvSpPr>
-        <p:spPr/>
-      </p:sp>
-    </p:spTree>
-  </p:cSld>
-  <p:clrMapOvr>
-    <a:masterClrMapping/>
-  </p:clrMapOvr>
-</p:notes>
-</file>
-
-<file path=ppt/notesSlides/notesSlide11.xml><?xml version="1.0" encoding="utf-8"?>
-<p:notes xmlns:a="http://schemas.openxmlformats.org/drawingml/2006/main" xmlns:p="http://schemas.openxmlformats.org/presentationml/2006/main" xmlns:r="http://schemas.openxmlformats.org/officeDocument/2006/relationships">
-  <p:cSld>
-    <p:spTree>
-      <p:nvGrpSpPr>
-        <p:cNvPr id="1" name=""/>
-        <p:cNvGrpSpPr/>
-        <p:nvPr/>
-      </p:nvGrpSpPr>
-      <p:grpSpPr>
-        <a:xfrm>
-          <a:off x="0" y="0"/>
-          <a:ext cx="0" cy="0"/>
-          <a:chOff x="0" y="0"/>
-          <a:chExt cx="0" cy="0"/>
-        </a:xfrm>
-      </p:grpSpPr>
-      <p:sp>
-        <p:nvSpPr>
-          <p:cNvPr id="2" name="Slide Image Placeholder 1"/>
-          <p:cNvSpPr>
-            <a:spLocks noGrp="1"/>
-          </p:cNvSpPr>
-          <p:nvPr>
-            <p:ph type="sldImg" idx="2"/>
-          </p:nvPr>
-        </p:nvSpPr>
-        <p:spPr/>
-      </p:sp>
-      <p:sp>
-        <p:nvSpPr>
-          <p:cNvPr id="3" name="Notes Placeholder 2"/>
-          <p:cNvSpPr>
-            <a:spLocks noGrp="1"/>
-          </p:cNvSpPr>
-          <p:nvPr>
-            <p:ph type="body" idx="3" sz="quarter"/>
-          </p:nvPr>
-        </p:nvSpPr>
-        <p:spPr/>
-        <p:txBody>
-          <a:bodyPr/>
-          <a:lstStyle/>
-          <a:p>
-            <a:r>
-              <a:t>YURI: Mostrar o estado inicial (seta 'início'), o final (círculo duplo) e os movimentos ε (tracejados). Percorrer uma cadeia aceita e uma rejeitada. Para ampliar o diagrama, abrir Expressões e AFNε &gt; ER-03 &gt; 'Abrir diagrama em tela cheia' na aplicação.</a:t>
-            </a:r>
-          </a:p>
-        </p:txBody>
-      </p:sp>
-      <p:sp>
-        <p:nvSpPr>
-          <p:cNvPr id="4" name="Slide Number Placeholder 3"/>
-          <p:cNvSpPr>
-            <a:spLocks noGrp="1"/>
-          </p:cNvSpPr>
-          <p:nvPr>
-            <p:ph type="sldNum" idx="5" sz="quarter"/>
-          </p:nvPr>
-        </p:nvSpPr>
-        <p:spPr/>
-      </p:sp>
-    </p:spTree>
-  </p:cSld>
-  <p:clrMapOvr>
-    <a:masterClrMapping/>
-  </p:clrMapOvr>
-</p:notes>
-</file>
-
-<file path=ppt/notesSlides/notesSlide12.xml><?xml version="1.0" encoding="utf-8"?>
-<p:notes xmlns:a="http://schemas.openxmlformats.org/drawingml/2006/main" xmlns:p="http://schemas.openxmlformats.org/presentationml/2006/main" xmlns:r="http://schemas.openxmlformats.org/officeDocument/2006/relationships">
-  <p:cSld>
-    <p:spTree>
-      <p:nvGrpSpPr>
-        <p:cNvPr id="1" name=""/>
-        <p:cNvGrpSpPr/>
-        <p:nvPr/>
-      </p:nvGrpSpPr>
-      <p:grpSpPr>
-        <a:xfrm>
-          <a:off x="0" y="0"/>
-          <a:ext cx="0" cy="0"/>
-          <a:chOff x="0" y="0"/>
-          <a:chExt cx="0" cy="0"/>
-        </a:xfrm>
-      </p:grpSpPr>
-      <p:sp>
-        <p:nvSpPr>
-          <p:cNvPr id="2" name="Slide Image Placeholder 1"/>
-          <p:cNvSpPr>
-            <a:spLocks noGrp="1"/>
-          </p:cNvSpPr>
-          <p:nvPr>
-            <p:ph type="sldImg" idx="2"/>
-          </p:nvPr>
-        </p:nvSpPr>
-        <p:spPr/>
-      </p:sp>
-      <p:sp>
-        <p:nvSpPr>
-          <p:cNvPr id="3" name="Notes Placeholder 2"/>
-          <p:cNvSpPr>
-            <a:spLocks noGrp="1"/>
-          </p:cNvSpPr>
-          <p:nvPr>
-            <p:ph type="body" idx="3" sz="quarter"/>
-          </p:nvPr>
-        </p:nvSpPr>
-        <p:spPr/>
-        <p:txBody>
-          <a:bodyPr/>
-          <a:lstStyle/>
-          <a:p>
-            <a:r>
-              <a:t>YURI: Explicar a duplicação do DDD: é o custo de exigir parênteses balanceados sem memória. Destacar os casos-limite: DDD 99 (maior existente) e número com um dígito a menos.</a:t>
-            </a:r>
-          </a:p>
-        </p:txBody>
-      </p:sp>
-      <p:sp>
-        <p:nvSpPr>
-          <p:cNvPr id="4" name="Slide Number Placeholder 3"/>
-          <p:cNvSpPr>
-            <a:spLocks noGrp="1"/>
-          </p:cNvSpPr>
-          <p:nvPr>
-            <p:ph type="sldNum" idx="5" sz="quarter"/>
-          </p:nvPr>
-        </p:nvSpPr>
-        <p:spPr/>
-      </p:sp>
-    </p:spTree>
-  </p:cSld>
-  <p:clrMapOvr>
-    <a:masterClrMapping/>
-  </p:clrMapOvr>
-</p:notes>
-</file>
-
-<file path=ppt/notesSlides/notesSlide13.xml><?xml version="1.0" encoding="utf-8"?>
-<p:notes xmlns:a="http://schemas.openxmlformats.org/drawingml/2006/main" xmlns:p="http://schemas.openxmlformats.org/presentationml/2006/main" xmlns:r="http://schemas.openxmlformats.org/officeDocument/2006/relationships">
-  <p:cSld>
-    <p:spTree>
-      <p:nvGrpSpPr>
-        <p:cNvPr id="1" name=""/>
-        <p:cNvGrpSpPr/>
-        <p:nvPr/>
-      </p:nvGrpSpPr>
-      <p:grpSpPr>
-        <a:xfrm>
-          <a:off x="0" y="0"/>
-          <a:ext cx="0" cy="0"/>
-          <a:chOff x="0" y="0"/>
-          <a:chExt cx="0" cy="0"/>
-        </a:xfrm>
-      </p:grpSpPr>
-      <p:sp>
-        <p:nvSpPr>
-          <p:cNvPr id="2" name="Slide Image Placeholder 1"/>
-          <p:cNvSpPr>
-            <a:spLocks noGrp="1"/>
-          </p:cNvSpPr>
-          <p:nvPr>
-            <p:ph type="sldImg" idx="2"/>
-          </p:nvPr>
-        </p:nvSpPr>
-        <p:spPr/>
-      </p:sp>
-      <p:sp>
-        <p:nvSpPr>
-          <p:cNvPr id="3" name="Notes Placeholder 2"/>
-          <p:cNvSpPr>
-            <a:spLocks noGrp="1"/>
-          </p:cNvSpPr>
-          <p:nvPr>
-            <p:ph type="body" idx="3" sz="quarter"/>
-          </p:nvPr>
-        </p:nvSpPr>
-        <p:spPr/>
-        <p:txBody>
-          <a:bodyPr/>
-          <a:lstStyle/>
-          <a:p>
-            <a:r>
-              <a:t>JOÃO: Ler a finalidade: Validar a data agendada para a coleta. Além do formato, impede dias inexistentes como 31/04 ou 30/02, e restringe o ano ao intervalo 1900–2099. Mostrar que cada atalho da sintaxe do código corresponde a um operador formal (tabela de equivalência). re.fullmatch exige que a cadeia inteira pertença à linguagem, como as âncoras ^ e $.</a:t>
-            </a:r>
-          </a:p>
-        </p:txBody>
-      </p:sp>
-      <p:sp>
-        <p:nvSpPr>
-          <p:cNvPr id="4" name="Slide Number Placeholder 3"/>
-          <p:cNvSpPr>
-            <a:spLocks noGrp="1"/>
-          </p:cNvSpPr>
-          <p:nvPr>
-            <p:ph type="sldNum" idx="5" sz="quarter"/>
-          </p:nvPr>
-        </p:nvSpPr>
-        <p:spPr/>
-      </p:sp>
-    </p:spTree>
-  </p:cSld>
-  <p:clrMapOvr>
-    <a:masterClrMapping/>
-  </p:clrMapOvr>
-</p:notes>
-</file>
-
-<file path=ppt/notesSlides/notesSlide14.xml><?xml version="1.0" encoding="utf-8"?>
-<p:notes xmlns:a="http://schemas.openxmlformats.org/drawingml/2006/main" xmlns:p="http://schemas.openxmlformats.org/presentationml/2006/main" xmlns:r="http://schemas.openxmlformats.org/officeDocument/2006/relationships">
-  <p:cSld>
-    <p:spTree>
-      <p:nvGrpSpPr>
-        <p:cNvPr id="1" name=""/>
-        <p:cNvGrpSpPr/>
-        <p:nvPr/>
-      </p:nvGrpSpPr>
-      <p:grpSpPr>
-        <a:xfrm>
-          <a:off x="0" y="0"/>
-          <a:ext cx="0" cy="0"/>
-          <a:chOff x="0" y="0"/>
-          <a:chExt cx="0" cy="0"/>
-        </a:xfrm>
-      </p:grpSpPr>
-      <p:sp>
-        <p:nvSpPr>
-          <p:cNvPr id="2" name="Slide Image Placeholder 1"/>
-          <p:cNvSpPr>
-            <a:spLocks noGrp="1"/>
-          </p:cNvSpPr>
-          <p:nvPr>
-            <p:ph type="sldImg" idx="2"/>
-          </p:nvPr>
-        </p:nvSpPr>
-        <p:spPr/>
-      </p:sp>
-      <p:sp>
-        <p:nvSpPr>
-          <p:cNvPr id="3" name="Notes Placeholder 2"/>
-          <p:cNvSpPr>
-            <a:spLocks noGrp="1"/>
-          </p:cNvSpPr>
-          <p:nvPr>
-            <p:ph type="body" idx="3" sz="quarter"/>
-          </p:nvPr>
-        </p:nvSpPr>
-        <p:spPr/>
-        <p:txBody>
-          <a:bodyPr/>
-          <a:lstStyle/>
-          <a:p>
-            <a:r>
-              <a:t>JOÃO: Mostrar o estado inicial (seta 'início'), o final (círculo duplo) e os movimentos ε (tracejados). Percorrer uma cadeia aceita e uma rejeitada. Para ampliar o diagrama, abrir Expressões e AFNε &gt; ER-04 &gt; 'Abrir diagrama em tela cheia' na aplicação.</a:t>
-            </a:r>
-          </a:p>
-        </p:txBody>
-      </p:sp>
-      <p:sp>
-        <p:nvSpPr>
-          <p:cNvPr id="4" name="Slide Number Placeholder 3"/>
-          <p:cNvSpPr>
-            <a:spLocks noGrp="1"/>
-          </p:cNvSpPr>
-          <p:nvPr>
-            <p:ph type="sldNum" idx="5" sz="quarter"/>
-          </p:nvPr>
-        </p:nvSpPr>
-        <p:spPr/>
-      </p:sp>
-    </p:spTree>
-  </p:cSld>
-  <p:clrMapOvr>
-    <a:masterClrMapping/>
-  </p:clrMapOvr>
-</p:notes>
-</file>
-
-<file path=ppt/notesSlides/notesSlide15.xml><?xml version="1.0" encoding="utf-8"?>
-<p:notes xmlns:a="http://schemas.openxmlformats.org/drawingml/2006/main" xmlns:p="http://schemas.openxmlformats.org/presentationml/2006/main" xmlns:r="http://schemas.openxmlformats.org/officeDocument/2006/relationships">
-  <p:cSld>
-    <p:spTree>
-      <p:nvGrpSpPr>
-        <p:cNvPr id="1" name=""/>
-        <p:cNvGrpSpPr/>
-        <p:nvPr/>
-      </p:nvGrpSpPr>
-      <p:grpSpPr>
-        <a:xfrm>
-          <a:off x="0" y="0"/>
-          <a:ext cx="0" cy="0"/>
-          <a:chOff x="0" y="0"/>
-          <a:chExt cx="0" cy="0"/>
-        </a:xfrm>
-      </p:grpSpPr>
-      <p:sp>
-        <p:nvSpPr>
-          <p:cNvPr id="2" name="Slide Image Placeholder 1"/>
-          <p:cNvSpPr>
-            <a:spLocks noGrp="1"/>
-          </p:cNvSpPr>
-          <p:nvPr>
-            <p:ph type="sldImg" idx="2"/>
-          </p:nvPr>
-        </p:nvSpPr>
-        <p:spPr/>
-      </p:sp>
-      <p:sp>
-        <p:nvSpPr>
-          <p:cNvPr id="3" name="Notes Placeholder 2"/>
-          <p:cNvSpPr>
-            <a:spLocks noGrp="1"/>
-          </p:cNvSpPr>
-          <p:nvPr>
-            <p:ph type="body" idx="3" sz="quarter"/>
-          </p:nvPr>
-        </p:nvSpPr>
-        <p:spPr/>
-        <p:txBody>
-          <a:bodyPr/>
-          <a:lstStyle/>
-          <a:p>
-            <a:r>
-              <a:t>JOÃO: Ler a finalidade: Validar o valor cobrado pelo frete no padrão monetário brasileiro: prefixo R$, parte inteira sem zeros à esquerda, separador de milhar opcional (mas consistente) e exatamente dois centavos após a vírgula. Mostrar que cada atalho da sintaxe do código corresponde a um operador formal (tabela de equivalência). re.fullmatch exige que a cadeia inteira pertença à linguagem, como as âncoras ^ e $.</a:t>
-            </a:r>
-          </a:p>
-        </p:txBody>
-      </p:sp>
-      <p:sp>
-        <p:nvSpPr>
-          <p:cNvPr id="4" name="Slide Number Placeholder 3"/>
-          <p:cNvSpPr>
-            <a:spLocks noGrp="1"/>
-          </p:cNvSpPr>
-          <p:nvPr>
-            <p:ph type="sldNum" idx="5" sz="quarter"/>
-          </p:nvPr>
-        </p:nvSpPr>
-        <p:spPr/>
-      </p:sp>
-    </p:spTree>
-  </p:cSld>
-  <p:clrMapOvr>
-    <a:masterClrMapping/>
-  </p:clrMapOvr>
-</p:notes>
-</file>
-
-<file path=ppt/notesSlides/notesSlide16.xml><?xml version="1.0" encoding="utf-8"?>
-<p:notes xmlns:a="http://schemas.openxmlformats.org/drawingml/2006/main" xmlns:p="http://schemas.openxmlformats.org/presentationml/2006/main" xmlns:r="http://schemas.openxmlformats.org/officeDocument/2006/relationships">
-  <p:cSld>
-    <p:spTree>
-      <p:nvGrpSpPr>
-        <p:cNvPr id="1" name=""/>
-        <p:cNvGrpSpPr/>
-        <p:nvPr/>
-      </p:nvGrpSpPr>
-      <p:grpSpPr>
-        <a:xfrm>
-          <a:off x="0" y="0"/>
-          <a:ext cx="0" cy="0"/>
-          <a:chOff x="0" y="0"/>
-          <a:chExt cx="0" cy="0"/>
-        </a:xfrm>
-      </p:grpSpPr>
-      <p:sp>
-        <p:nvSpPr>
-          <p:cNvPr id="2" name="Slide Image Placeholder 1"/>
-          <p:cNvSpPr>
-            <a:spLocks noGrp="1"/>
-          </p:cNvSpPr>
-          <p:nvPr>
-            <p:ph type="sldImg" idx="2"/>
-          </p:nvPr>
-        </p:nvSpPr>
-        <p:spPr/>
-      </p:sp>
-      <p:sp>
-        <p:nvSpPr>
-          <p:cNvPr id="3" name="Notes Placeholder 2"/>
-          <p:cNvSpPr>
-            <a:spLocks noGrp="1"/>
-          </p:cNvSpPr>
-          <p:nvPr>
-            <p:ph type="body" idx="3" sz="quarter"/>
-          </p:nvPr>
-        </p:nvSpPr>
-        <p:spPr/>
-        <p:txBody>
-          <a:bodyPr/>
-          <a:lstStyle/>
-          <a:p>
-            <a:r>
-              <a:t>JOÃO: Mostrar o estado inicial (seta 'início'), o final (círculo duplo) e os movimentos ε (tracejados). Percorrer uma cadeia aceita e uma rejeitada. Para ampliar o diagrama, abrir Expressões e AFNε &gt; ER-05 &gt; 'Abrir diagrama em tela cheia' na aplicação.</a:t>
-            </a:r>
-          </a:p>
-        </p:txBody>
-      </p:sp>
-      <p:sp>
-        <p:nvSpPr>
-          <p:cNvPr id="4" name="Slide Number Placeholder 3"/>
-          <p:cNvSpPr>
-            <a:spLocks noGrp="1"/>
-          </p:cNvSpPr>
-          <p:nvPr>
-            <p:ph type="sldNum" idx="5" sz="quarter"/>
-          </p:nvPr>
-        </p:nvSpPr>
-        <p:spPr/>
-      </p:sp>
-    </p:spTree>
-  </p:cSld>
-  <p:clrMapOvr>
-    <a:masterClrMapping/>
-  </p:clrMapOvr>
-</p:notes>
-</file>
-
-<file path=ppt/notesSlides/notesSlide17.xml><?xml version="1.0" encoding="utf-8"?>
-<p:notes xmlns:a="http://schemas.openxmlformats.org/drawingml/2006/main" xmlns:p="http://schemas.openxmlformats.org/presentationml/2006/main" xmlns:r="http://schemas.openxmlformats.org/officeDocument/2006/relationships">
-  <p:cSld>
-    <p:spTree>
-      <p:nvGrpSpPr>
-        <p:cNvPr id="1" name=""/>
-        <p:cNvGrpSpPr/>
-        <p:nvPr/>
-      </p:nvGrpSpPr>
-      <p:grpSpPr>
-        <a:xfrm>
-          <a:off x="0" y="0"/>
-          <a:ext cx="0" cy="0"/>
-          <a:chOff x="0" y="0"/>
-          <a:chExt cx="0" cy="0"/>
-        </a:xfrm>
-      </p:grpSpPr>
-      <p:sp>
-        <p:nvSpPr>
-          <p:cNvPr id="2" name="Slide Image Placeholder 1"/>
-          <p:cNvSpPr>
-            <a:spLocks noGrp="1"/>
-          </p:cNvSpPr>
-          <p:nvPr>
-            <p:ph type="sldImg" idx="2"/>
-          </p:nvPr>
-        </p:nvSpPr>
-        <p:spPr/>
-      </p:sp>
-      <p:sp>
-        <p:nvSpPr>
-          <p:cNvPr id="3" name="Notes Placeholder 2"/>
-          <p:cNvSpPr>
-            <a:spLocks noGrp="1"/>
-          </p:cNvSpPr>
-          <p:nvPr>
-            <p:ph type="body" idx="3" sz="quarter"/>
-          </p:nvPr>
-        </p:nvSpPr>
-        <p:spPr/>
-        <p:txBody>
-          <a:bodyPr/>
-          <a:lstStyle/>
-          <a:p>
-            <a:r>
-              <a:t>JOÃO: O diagnóstico usa o AFNε: o programa lê a cadeia símbolo a símbolo e informa onde o conjunto de estados ficou vazio. Não fazemos strip para não mudar a linguagem.</a:t>
-            </a:r>
-          </a:p>
-        </p:txBody>
-      </p:sp>
-      <p:sp>
-        <p:nvSpPr>
-          <p:cNvPr id="4" name="Slide Number Placeholder 3"/>
-          <p:cNvSpPr>
-            <a:spLocks noGrp="1"/>
-          </p:cNvSpPr>
-          <p:nvPr>
-            <p:ph type="sldNum" idx="5" sz="quarter"/>
-          </p:nvPr>
-        </p:nvSpPr>
-        <p:spPr/>
-      </p:sp>
-    </p:spTree>
-  </p:cSld>
-  <p:clrMapOvr>
-    <a:masterClrMapping/>
-  </p:clrMapOvr>
-</p:notes>
-</file>
-
-<file path=ppt/notesSlides/notesSlide18.xml><?xml version="1.0" encoding="utf-8"?>
-<p:notes xmlns:a="http://schemas.openxmlformats.org/drawingml/2006/main" xmlns:p="http://schemas.openxmlformats.org/presentationml/2006/main" xmlns:r="http://schemas.openxmlformats.org/officeDocument/2006/relationships">
-  <p:cSld>
-    <p:spTree>
-      <p:nvGrpSpPr>
-        <p:cNvPr id="1" name=""/>
-        <p:cNvGrpSpPr/>
-        <p:nvPr/>
-      </p:nvGrpSpPr>
-      <p:grpSpPr>
-        <a:xfrm>
-          <a:off x="0" y="0"/>
-          <a:ext cx="0" cy="0"/>
-          <a:chOff x="0" y="0"/>
-          <a:chExt cx="0" cy="0"/>
-        </a:xfrm>
-      </p:grpSpPr>
-      <p:sp>
-        <p:nvSpPr>
-          <p:cNvPr id="2" name="Slide Image Placeholder 1"/>
-          <p:cNvSpPr>
-            <a:spLocks noGrp="1"/>
-          </p:cNvSpPr>
-          <p:nvPr>
-            <p:ph type="sldImg" idx="2"/>
-          </p:nvPr>
-        </p:nvSpPr>
-        <p:spPr/>
-      </p:sp>
-      <p:sp>
-        <p:nvSpPr>
-          <p:cNvPr id="3" name="Notes Placeholder 2"/>
-          <p:cNvSpPr>
-            <a:spLocks noGrp="1"/>
-          </p:cNvSpPr>
-          <p:nvPr>
-            <p:ph type="body" idx="3" sz="quarter"/>
-          </p:nvPr>
-        </p:nvSpPr>
-        <p:spPr/>
-        <p:txBody>
-          <a:bodyPr/>
-          <a:lstStyle/>
-          <a:p>
-            <a:r>
-              <a:t>YURI: Demonstração ao vivo. (1) Validar BRA2E19 em 'Identificar automaticamente'. (2) Validar (23) 91234-5678 e ler a mensagem. (3) Processar planilha &gt; Usar arquivo de exemplo; baixar o relatório. (4) Expressões e AFNε &gt; ER-02 &gt; simular BRA-2E19 e mostrar o conjunto vazio no passo 6. Se o professor pedir outra entrada, digitar na página inicial.</a:t>
-            </a:r>
-          </a:p>
-        </p:txBody>
-      </p:sp>
-      <p:sp>
-        <p:nvSpPr>
-          <p:cNvPr id="4" name="Slide Number Placeholder 3"/>
-          <p:cNvSpPr>
-            <a:spLocks noGrp="1"/>
-          </p:cNvSpPr>
-          <p:nvPr>
-            <p:ph type="sldNum" idx="5" sz="quarter"/>
-          </p:nvPr>
-        </p:nvSpPr>
-        <p:spPr/>
-      </p:sp>
-    </p:spTree>
-  </p:cSld>
-  <p:clrMapOvr>
-    <a:masterClrMapping/>
-  </p:clrMapOvr>
-</p:notes>
-</file>
-
-<file path=ppt/notesSlides/notesSlide19.xml><?xml version="1.0" encoding="utf-8"?>
-<p:notes xmlns:a="http://schemas.openxmlformats.org/drawingml/2006/main" xmlns:p="http://schemas.openxmlformats.org/presentationml/2006/main" xmlns:r="http://schemas.openxmlformats.org/officeDocument/2006/relationships">
-  <p:cSld>
-    <p:spTree>
-      <p:nvGrpSpPr>
-        <p:cNvPr id="1" name=""/>
-        <p:cNvGrpSpPr/>
-        <p:nvPr/>
-      </p:nvGrpSpPr>
-      <p:grpSpPr>
-        <a:xfrm>
-          <a:off x="0" y="0"/>
-          <a:ext cx="0" cy="0"/>
-          <a:chOff x="0" y="0"/>
-          <a:chExt cx="0" cy="0"/>
-        </a:xfrm>
-      </p:grpSpPr>
-      <p:sp>
-        <p:nvSpPr>
-          <p:cNvPr id="2" name="Slide Image Placeholder 1"/>
-          <p:cNvSpPr>
-            <a:spLocks noGrp="1"/>
-          </p:cNvSpPr>
-          <p:nvPr>
-            <p:ph type="sldImg" idx="2"/>
-          </p:nvPr>
-        </p:nvSpPr>
-        <p:spPr/>
-      </p:sp>
-      <p:sp>
-        <p:nvSpPr>
-          <p:cNvPr id="3" name="Notes Placeholder 2"/>
-          <p:cNvSpPr>
-            <a:spLocks noGrp="1"/>
-          </p:cNvSpPr>
-          <p:nvPr>
-            <p:ph type="body" idx="3" sz="quarter"/>
-          </p:nvPr>
-        </p:nvSpPr>
-        <p:spPr/>
-        <p:txBody>
-          <a:bodyPr/>
-          <a:lstStyle/>
-          <a:p>
-            <a:r>
-              <a:t>JOÃO: Cada caso é testado duas vezes, com a regex e com o AFNε. A comparação em 15.000 cadeias geradas por mutação mostra que autômato e código aceitam a mesma linguagem. Os falsos positivos são limitações documentadas, não erros.</a:t>
-            </a:r>
-          </a:p>
-        </p:txBody>
-      </p:sp>
-      <p:sp>
-        <p:nvSpPr>
-          <p:cNvPr id="4" name="Slide Number Placeholder 3"/>
-          <p:cNvSpPr>
-            <a:spLocks noGrp="1"/>
-          </p:cNvSpPr>
-          <p:nvPr>
-            <p:ph type="sldNum" idx="5" sz="quarter"/>
-          </p:nvPr>
-        </p:nvSpPr>
-        <p:spPr/>
-      </p:sp>
-    </p:spTree>
-  </p:cSld>
-  <p:clrMapOvr>
-    <a:masterClrMapping/>
-  </p:clrMapOvr>
-</p:notes>
-</file>
-
-<file path=ppt/notesSlides/notesSlide2.xml><?xml version="1.0" encoding="utf-8"?>
-<p:notes xmlns:a="http://schemas.openxmlformats.org/drawingml/2006/main" xmlns:p="http://schemas.openxmlformats.org/presentationml/2006/main" xmlns:r="http://schemas.openxmlformats.org/officeDocument/2006/relationships">
-  <p:cSld>
-    <p:spTree>
-      <p:nvGrpSpPr>
-        <p:cNvPr id="1" name=""/>
-        <p:cNvGrpSpPr/>
-        <p:nvPr/>
-      </p:nvGrpSpPr>
-      <p:grpSpPr>
-        <a:xfrm>
-          <a:off x="0" y="0"/>
-          <a:ext cx="0" cy="0"/>
-          <a:chOff x="0" y="0"/>
-          <a:chExt cx="0" cy="0"/>
-        </a:xfrm>
-      </p:grpSpPr>
-      <p:sp>
-        <p:nvSpPr>
-          <p:cNvPr id="2" name="Slide Image Placeholder 1"/>
-          <p:cNvSpPr>
-            <a:spLocks noGrp="1"/>
-          </p:cNvSpPr>
-          <p:nvPr>
-            <p:ph type="sldImg" idx="2"/>
-          </p:nvPr>
-        </p:nvSpPr>
-        <p:spPr/>
-      </p:sp>
-      <p:sp>
-        <p:nvSpPr>
-          <p:cNvPr id="3" name="Notes Placeholder 2"/>
-          <p:cNvSpPr>
-            <a:spLocks noGrp="1"/>
-          </p:cNvSpPr>
-          <p:nvPr>
-            <p:ph type="body" idx="3" sz="quarter"/>
-          </p:nvPr>
-        </p:nvSpPr>
-        <p:spPr/>
-        <p:txBody>
-          <a:bodyPr/>
-          <a:lstStyle/>
-          <a:p>
-            <a:r>
-              <a:t>YURI: Contextualizar o problema. Cada linha da direita é um erro real que o programa detecta; todos estão no arquivo dados/fretes_exemplo.csv.</a:t>
-            </a:r>
-          </a:p>
-        </p:txBody>
-      </p:sp>
-      <p:sp>
-        <p:nvSpPr>
-          <p:cNvPr id="4" name="Slide Number Placeholder 3"/>
-          <p:cNvSpPr>
-            <a:spLocks noGrp="1"/>
-          </p:cNvSpPr>
-          <p:nvPr>
-            <p:ph type="sldNum" idx="5" sz="quarter"/>
-          </p:nvPr>
-        </p:nvSpPr>
-        <p:spPr/>
-      </p:sp>
-    </p:spTree>
-  </p:cSld>
-  <p:clrMapOvr>
-    <a:masterClrMapping/>
-  </p:clrMapOvr>
-</p:notes>
-</file>
-
-<file path=ppt/notesSlides/notesSlide20.xml><?xml version="1.0" encoding="utf-8"?>
-<p:notes xmlns:a="http://schemas.openxmlformats.org/drawingml/2006/main" xmlns:p="http://schemas.openxmlformats.org/presentationml/2006/main" xmlns:r="http://schemas.openxmlformats.org/officeDocument/2006/relationships">
-  <p:cSld>
-    <p:spTree>
-      <p:nvGrpSpPr>
-        <p:cNvPr id="1" name=""/>
-        <p:cNvGrpSpPr/>
-        <p:nvPr/>
-      </p:nvGrpSpPr>
-      <p:grpSpPr>
-        <a:xfrm>
-          <a:off x="0" y="0"/>
-          <a:ext cx="0" cy="0"/>
-          <a:chOff x="0" y="0"/>
-          <a:chExt cx="0" cy="0"/>
-        </a:xfrm>
-      </p:grpSpPr>
-      <p:sp>
-        <p:nvSpPr>
-          <p:cNvPr id="2" name="Slide Image Placeholder 1"/>
-          <p:cNvSpPr>
-            <a:spLocks noGrp="1"/>
-          </p:cNvSpPr>
-          <p:nvPr>
-            <p:ph type="sldImg" idx="2"/>
-          </p:nvPr>
-        </p:nvSpPr>
-        <p:spPr/>
-      </p:sp>
-      <p:sp>
-        <p:nvSpPr>
-          <p:cNvPr id="3" name="Notes Placeholder 2"/>
-          <p:cNvSpPr>
-            <a:spLocks noGrp="1"/>
-          </p:cNvSpPr>
-          <p:nvPr>
-            <p:ph type="body" idx="3" sz="quarter"/>
-          </p:nvPr>
-        </p:nvSpPr>
-        <p:spPr/>
-        <p:txBody>
-          <a:bodyPr/>
-          <a:lstStyle/>
-          <a:p>
-            <a:r>
-              <a:t>JOÃO: Limitações são decisões conscientes: a ER descreve formato. As melhorias mostram como evoluir o trabalho, incluindo conteúdos da disciplina (AFD e minimização).</a:t>
-            </a:r>
-          </a:p>
-        </p:txBody>
-      </p:sp>
-      <p:sp>
-        <p:nvSpPr>
-          <p:cNvPr id="4" name="Slide Number Placeholder 3"/>
-          <p:cNvSpPr>
-            <a:spLocks noGrp="1"/>
-          </p:cNvSpPr>
-          <p:nvPr>
-            <p:ph type="sldNum" idx="5" sz="quarter"/>
-          </p:nvPr>
-        </p:nvSpPr>
-        <p:spPr/>
-      </p:sp>
-    </p:spTree>
-  </p:cSld>
-  <p:clrMapOvr>
-    <a:masterClrMapping/>
-  </p:clrMapOvr>
-</p:notes>
-</file>
-
-<file path=ppt/notesSlides/notesSlide21.xml><?xml version="1.0" encoding="utf-8"?>
-<p:notes xmlns:a="http://schemas.openxmlformats.org/drawingml/2006/main" xmlns:p="http://schemas.openxmlformats.org/presentationml/2006/main" xmlns:r="http://schemas.openxmlformats.org/officeDocument/2006/relationships">
-  <p:cSld>
-    <p:spTree>
-      <p:nvGrpSpPr>
-        <p:cNvPr id="1" name=""/>
-        <p:cNvGrpSpPr/>
-        <p:nvPr/>
-      </p:nvGrpSpPr>
-      <p:grpSpPr>
-        <a:xfrm>
-          <a:off x="0" y="0"/>
-          <a:ext cx="0" cy="0"/>
-          <a:chOff x="0" y="0"/>
-          <a:chExt cx="0" cy="0"/>
-        </a:xfrm>
-      </p:grpSpPr>
-      <p:sp>
-        <p:nvSpPr>
-          <p:cNvPr id="2" name="Slide Image Placeholder 1"/>
-          <p:cNvSpPr>
-            <a:spLocks noGrp="1"/>
-          </p:cNvSpPr>
-          <p:nvPr>
-            <p:ph type="sldImg" idx="2"/>
-          </p:nvPr>
-        </p:nvSpPr>
-        <p:spPr/>
-      </p:sp>
-      <p:sp>
-        <p:nvSpPr>
-          <p:cNvPr id="3" name="Notes Placeholder 2"/>
-          <p:cNvSpPr>
-            <a:spLocks noGrp="1"/>
-          </p:cNvSpPr>
-          <p:nvPr>
-            <p:ph type="body" idx="3" sz="quarter"/>
-          </p:nvPr>
-        </p:nvSpPr>
-        <p:spPr/>
-        <p:txBody>
-          <a:bodyPr/>
-          <a:lstStyle/>
-          <a:p>
-            <a:r>
-              <a:t>YURI: Apresentar a contribuição de cada integrante e a declaração de uso de IA exigida pelo professor.</a:t>
-            </a:r>
-          </a:p>
-        </p:txBody>
-      </p:sp>
-      <p:sp>
-        <p:nvSpPr>
-          <p:cNvPr id="4" name="Slide Number Placeholder 3"/>
-          <p:cNvSpPr>
-            <a:spLocks noGrp="1"/>
-          </p:cNvSpPr>
-          <p:nvPr>
-            <p:ph type="sldNum" idx="5" sz="quarter"/>
-          </p:nvPr>
-        </p:nvSpPr>
-        <p:spPr/>
-      </p:sp>
-    </p:spTree>
-  </p:cSld>
-  <p:clrMapOvr>
-    <a:masterClrMapping/>
-  </p:clrMapOvr>
-</p:notes>
-</file>
-
-<file path=ppt/notesSlides/notesSlide22.xml><?xml version="1.0" encoding="utf-8"?>
-<p:notes xmlns:a="http://schemas.openxmlformats.org/drawingml/2006/main" xmlns:p="http://schemas.openxmlformats.org/presentationml/2006/main" xmlns:r="http://schemas.openxmlformats.org/officeDocument/2006/relationships">
-  <p:cSld>
-    <p:spTree>
-      <p:nvGrpSpPr>
-        <p:cNvPr id="1" name=""/>
-        <p:cNvGrpSpPr/>
-        <p:nvPr/>
-      </p:nvGrpSpPr>
-      <p:grpSpPr>
-        <a:xfrm>
-          <a:off x="0" y="0"/>
-          <a:ext cx="0" cy="0"/>
-          <a:chOff x="0" y="0"/>
-          <a:chExt cx="0" cy="0"/>
-        </a:xfrm>
-      </p:grpSpPr>
-      <p:sp>
-        <p:nvSpPr>
-          <p:cNvPr id="2" name="Slide Image Placeholder 1"/>
-          <p:cNvSpPr>
-            <a:spLocks noGrp="1"/>
-          </p:cNvSpPr>
-          <p:nvPr>
-            <p:ph type="sldImg" idx="2"/>
-          </p:nvPr>
-        </p:nvSpPr>
-        <p:spPr/>
-      </p:sp>
-      <p:sp>
-        <p:nvSpPr>
-          <p:cNvPr id="3" name="Notes Placeholder 2"/>
-          <p:cNvSpPr>
-            <a:spLocks noGrp="1"/>
-          </p:cNvSpPr>
-          <p:nvPr>
-            <p:ph type="body" idx="3" sz="quarter"/>
-          </p:nvPr>
-        </p:nvSpPr>
-        <p:spPr/>
-        <p:txBody>
-          <a:bodyPr/>
-          <a:lstStyle/>
-          <a:p>
-            <a:r>
-              <a:t>TODOS: Abrir para perguntas. Deixar a aplicação aberta para o professor sugerir novas entradas.</a:t>
-            </a:r>
-          </a:p>
-        </p:txBody>
-      </p:sp>
-      <p:sp>
-        <p:nvSpPr>
-          <p:cNvPr id="4" name="Slide Number Placeholder 3"/>
-          <p:cNvSpPr>
-            <a:spLocks noGrp="1"/>
-          </p:cNvSpPr>
-          <p:nvPr>
-            <p:ph type="sldNum" idx="5" sz="quarter"/>
-          </p:nvPr>
-        </p:nvSpPr>
-        <p:spPr/>
-      </p:sp>
-    </p:spTree>
-  </p:cSld>
-  <p:clrMapOvr>
-    <a:masterClrMapping/>
-  </p:clrMapOvr>
-</p:notes>
-</file>
-
-<file path=ppt/notesSlides/notesSlide3.xml><?xml version="1.0" encoding="utf-8"?>
-<p:notes xmlns:a="http://schemas.openxmlformats.org/drawingml/2006/main" xmlns:p="http://schemas.openxmlformats.org/presentationml/2006/main" xmlns:r="http://schemas.openxmlformats.org/officeDocument/2006/relationships">
-  <p:cSld>
-    <p:spTree>
-      <p:nvGrpSpPr>
-        <p:cNvPr id="1" name=""/>
-        <p:cNvGrpSpPr/>
-        <p:nvPr/>
-      </p:nvGrpSpPr>
-      <p:grpSpPr>
-        <a:xfrm>
-          <a:off x="0" y="0"/>
-          <a:ext cx="0" cy="0"/>
-          <a:chOff x="0" y="0"/>
-          <a:chExt cx="0" cy="0"/>
-        </a:xfrm>
-      </p:grpSpPr>
-      <p:sp>
-        <p:nvSpPr>
-          <p:cNvPr id="2" name="Slide Image Placeholder 1"/>
-          <p:cNvSpPr>
-            <a:spLocks noGrp="1"/>
-          </p:cNvSpPr>
-          <p:nvPr>
-            <p:ph type="sldImg" idx="2"/>
-          </p:nvPr>
-        </p:nvSpPr>
-        <p:spPr/>
-      </p:sp>
-      <p:sp>
-        <p:nvSpPr>
-          <p:cNvPr id="3" name="Notes Placeholder 2"/>
-          <p:cNvSpPr>
-            <a:spLocks noGrp="1"/>
-          </p:cNvSpPr>
-          <p:nvPr>
-            <p:ph type="body" idx="3" sz="quarter"/>
-          </p:nvPr>
-        </p:nvSpPr>
-        <p:spPr/>
-        <p:txBody>
-          <a:bodyPr/>
-          <a:lstStyle/>
-          <a:p>
-            <a:r>
-              <a:t>YURI: Explicar as três funções da aplicação: validar um valor, processar uma planilha e simular o AFNε. Tecnologias: Python, Flask para a interface, re para as ERs, pytest e Graphviz.</a:t>
-            </a:r>
-          </a:p>
-        </p:txBody>
-      </p:sp>
-      <p:sp>
-        <p:nvSpPr>
-          <p:cNvPr id="4" name="Slide Number Placeholder 3"/>
-          <p:cNvSpPr>
-            <a:spLocks noGrp="1"/>
-          </p:cNvSpPr>
-          <p:nvPr>
-            <p:ph type="sldNum" idx="5" sz="quarter"/>
-          </p:nvPr>
-        </p:nvSpPr>
-        <p:spPr/>
-      </p:sp>
-    </p:spTree>
-  </p:cSld>
-  <p:clrMapOvr>
-    <a:masterClrMapping/>
-  </p:clrMapOvr>
-</p:notes>
-</file>
-
-<file path=ppt/notesSlides/notesSlide4.xml><?xml version="1.0" encoding="utf-8"?>
-<p:notes xmlns:a="http://schemas.openxmlformats.org/drawingml/2006/main" xmlns:p="http://schemas.openxmlformats.org/presentationml/2006/main" xmlns:r="http://schemas.openxmlformats.org/officeDocument/2006/relationships">
-  <p:cSld>
-    <p:spTree>
-      <p:nvGrpSpPr>
-        <p:cNvPr id="1" name=""/>
-        <p:cNvGrpSpPr/>
-        <p:nvPr/>
-      </p:nvGrpSpPr>
-      <p:grpSpPr>
-        <a:xfrm>
-          <a:off x="0" y="0"/>
-          <a:ext cx="0" cy="0"/>
-          <a:chOff x="0" y="0"/>
-          <a:chExt cx="0" cy="0"/>
-        </a:xfrm>
-      </p:grpSpPr>
-      <p:sp>
-        <p:nvSpPr>
-          <p:cNvPr id="2" name="Slide Image Placeholder 1"/>
-          <p:cNvSpPr>
-            <a:spLocks noGrp="1"/>
-          </p:cNvSpPr>
-          <p:nvPr>
-            <p:ph type="sldImg" idx="2"/>
-          </p:nvPr>
-        </p:nvSpPr>
-        <p:spPr/>
-      </p:sp>
-      <p:sp>
-        <p:nvSpPr>
-          <p:cNvPr id="3" name="Notes Placeholder 2"/>
-          <p:cNvSpPr>
-            <a:spLocks noGrp="1"/>
-          </p:cNvSpPr>
-          <p:nvPr>
-            <p:ph type="body" idx="3" sz="quarter"/>
-          </p:nvPr>
-        </p:nvSpPr>
-        <p:spPr/>
-        <p:txBody>
-          <a:bodyPr/>
-          <a:lstStyle/>
-          <a:p>
-            <a:r>
-              <a:t>YURI: Nada foi escrito duas vezes. O validador, os testes, os diagramas e a documentação leem as ERs do mesmo módulo. O AFNε não é desenhado à mão: é gerado do padrão que o programa usa.</a:t>
-            </a:r>
-          </a:p>
-        </p:txBody>
-      </p:sp>
-      <p:sp>
-        <p:nvSpPr>
-          <p:cNvPr id="4" name="Slide Number Placeholder 3"/>
-          <p:cNvSpPr>
-            <a:spLocks noGrp="1"/>
-          </p:cNvSpPr>
-          <p:nvPr>
-            <p:ph type="sldNum" idx="5" sz="quarter"/>
-          </p:nvPr>
-        </p:nvSpPr>
-        <p:spPr/>
-      </p:sp>
-    </p:spTree>
-  </p:cSld>
-  <p:clrMapOvr>
-    <a:masterClrMapping/>
-  </p:clrMapOvr>
-</p:notes>
-</file>
-
-<file path=ppt/notesSlides/notesSlide5.xml><?xml version="1.0" encoding="utf-8"?>
-<p:notes xmlns:a="http://schemas.openxmlformats.org/drawingml/2006/main" xmlns:p="http://schemas.openxmlformats.org/presentationml/2006/main" xmlns:r="http://schemas.openxmlformats.org/officeDocument/2006/relationships">
-  <p:cSld>
-    <p:spTree>
-      <p:nvGrpSpPr>
-        <p:cNvPr id="1" name=""/>
-        <p:cNvGrpSpPr/>
-        <p:nvPr/>
-      </p:nvGrpSpPr>
-      <p:grpSpPr>
-        <a:xfrm>
-          <a:off x="0" y="0"/>
-          <a:ext cx="0" cy="0"/>
-          <a:chOff x="0" y="0"/>
-          <a:chExt cx="0" cy="0"/>
-        </a:xfrm>
-      </p:grpSpPr>
-      <p:sp>
-        <p:nvSpPr>
-          <p:cNvPr id="2" name="Slide Image Placeholder 1"/>
-          <p:cNvSpPr>
-            <a:spLocks noGrp="1"/>
-          </p:cNvSpPr>
-          <p:nvPr>
-            <p:ph type="sldImg" idx="2"/>
-          </p:nvPr>
-        </p:nvSpPr>
-        <p:spPr/>
-      </p:sp>
-      <p:sp>
-        <p:nvSpPr>
-          <p:cNvPr id="3" name="Notes Placeholder 2"/>
-          <p:cNvSpPr>
-            <a:spLocks noGrp="1"/>
-          </p:cNvSpPr>
-          <p:nvPr>
-            <p:ph type="body" idx="3" sz="quarter"/>
-          </p:nvPr>
-        </p:nvSpPr>
-        <p:spPr/>
-        <p:txBody>
-          <a:bodyPr/>
-          <a:lstStyle/>
-          <a:p>
-            <a:r>
-              <a:t>YURI: Explicar as regras de Thompson. Cada operador vira um fragmento com um estado inicial e um final. Estes mini-diagramas foram gerados pelo mesmo código que gera os AFNε das cinco ERs.</a:t>
-            </a:r>
-          </a:p>
-        </p:txBody>
-      </p:sp>
-      <p:sp>
-        <p:nvSpPr>
-          <p:cNvPr id="4" name="Slide Number Placeholder 3"/>
-          <p:cNvSpPr>
-            <a:spLocks noGrp="1"/>
-          </p:cNvSpPr>
-          <p:nvPr>
-            <p:ph type="sldNum" idx="5" sz="quarter"/>
-          </p:nvPr>
-        </p:nvSpPr>
-        <p:spPr/>
-      </p:sp>
-    </p:spTree>
-  </p:cSld>
-  <p:clrMapOvr>
-    <a:masterClrMapping/>
-  </p:clrMapOvr>
-</p:notes>
-</file>
-
-<file path=ppt/notesSlides/notesSlide6.xml><?xml version="1.0" encoding="utf-8"?>
-<p:notes xmlns:a="http://schemas.openxmlformats.org/drawingml/2006/main" xmlns:p="http://schemas.openxmlformats.org/presentationml/2006/main" xmlns:r="http://schemas.openxmlformats.org/officeDocument/2006/relationships">
-  <p:cSld>
-    <p:spTree>
-      <p:nvGrpSpPr>
-        <p:cNvPr id="1" name=""/>
-        <p:cNvGrpSpPr/>
-        <p:nvPr/>
-      </p:nvGrpSpPr>
-      <p:grpSpPr>
-        <a:xfrm>
-          <a:off x="0" y="0"/>
-          <a:ext cx="0" cy="0"/>
-          <a:chOff x="0" y="0"/>
-          <a:chExt cx="0" cy="0"/>
-        </a:xfrm>
-      </p:grpSpPr>
-      <p:sp>
-        <p:nvSpPr>
-          <p:cNvPr id="2" name="Slide Image Placeholder 1"/>
-          <p:cNvSpPr>
-            <a:spLocks noGrp="1"/>
-          </p:cNvSpPr>
-          <p:nvPr>
-            <p:ph type="sldImg" idx="2"/>
-          </p:nvPr>
-        </p:nvSpPr>
-        <p:spPr/>
-      </p:sp>
-      <p:sp>
-        <p:nvSpPr>
-          <p:cNvPr id="3" name="Notes Placeholder 2"/>
-          <p:cNvSpPr>
-            <a:spLocks noGrp="1"/>
-          </p:cNvSpPr>
-          <p:nvPr>
-            <p:ph type="body" idx="3" sz="quarter"/>
-          </p:nvPr>
-        </p:nvSpPr>
-        <p:spPr/>
-        <p:txBody>
-          <a:bodyPr/>
-          <a:lstStyle/>
-          <a:p>
-            <a:r>
-              <a:t>PEDRO: Ler a finalidade: Validar o CNPJ da empresa que contrata o frete. Aceita o novo CNPJ alfanumérico (IN RFB nº 2.229/2024, em uso desde julho de 2026) e o formato numérico tradicional, com a máscara XX.XXX.XXX/XXXX-DD ou sem máscara. Mostrar que cada atalho da sintaxe do código corresponde a um operador formal (tabela de equivalência). re.fullmatch exige que a cadeia inteira pertença à linguagem, como as âncoras ^ e $.</a:t>
-            </a:r>
-          </a:p>
-        </p:txBody>
-      </p:sp>
-      <p:sp>
-        <p:nvSpPr>
-          <p:cNvPr id="4" name="Slide Number Placeholder 3"/>
-          <p:cNvSpPr>
-            <a:spLocks noGrp="1"/>
-          </p:cNvSpPr>
-          <p:nvPr>
-            <p:ph type="sldNum" idx="5" sz="quarter"/>
-          </p:nvPr>
-        </p:nvSpPr>
-        <p:spPr/>
-      </p:sp>
-    </p:spTree>
-  </p:cSld>
-  <p:clrMapOvr>
-    <a:masterClrMapping/>
-  </p:clrMapOvr>
-</p:notes>
-</file>
-
-<file path=ppt/notesSlides/notesSlide7.xml><?xml version="1.0" encoding="utf-8"?>
-<p:notes xmlns:a="http://schemas.openxmlformats.org/drawingml/2006/main" xmlns:p="http://schemas.openxmlformats.org/presentationml/2006/main" xmlns:r="http://schemas.openxmlformats.org/officeDocument/2006/relationships">
-  <p:cSld>
-    <p:spTree>
-      <p:nvGrpSpPr>
-        <p:cNvPr id="1" name=""/>
-        <p:cNvGrpSpPr/>
-        <p:nvPr/>
-      </p:nvGrpSpPr>
-      <p:grpSpPr>
-        <a:xfrm>
-          <a:off x="0" y="0"/>
-          <a:ext cx="0" cy="0"/>
-          <a:chOff x="0" y="0"/>
-          <a:chExt cx="0" cy="0"/>
-        </a:xfrm>
-      </p:grpSpPr>
-      <p:sp>
-        <p:nvSpPr>
-          <p:cNvPr id="2" name="Slide Image Placeholder 1"/>
-          <p:cNvSpPr>
-            <a:spLocks noGrp="1"/>
-          </p:cNvSpPr>
-          <p:nvPr>
-            <p:ph type="sldImg" idx="2"/>
-          </p:nvPr>
-        </p:nvSpPr>
-        <p:spPr/>
-      </p:sp>
-      <p:sp>
-        <p:nvSpPr>
-          <p:cNvPr id="3" name="Notes Placeholder 2"/>
-          <p:cNvSpPr>
-            <a:spLocks noGrp="1"/>
-          </p:cNvSpPr>
-          <p:nvPr>
-            <p:ph type="body" idx="3" sz="quarter"/>
-          </p:nvPr>
-        </p:nvSpPr>
-        <p:spPr/>
-        <p:txBody>
-          <a:bodyPr/>
-          <a:lstStyle/>
-          <a:p>
-            <a:r>
-              <a:t>PEDRO: Mostrar o estado inicial (seta 'início'), o final (círculo duplo) e os movimentos ε (tracejados). Percorrer uma cadeia aceita e uma rejeitada. Para ampliar o diagrama, abrir Expressões e AFNε &gt; ER-01 &gt; 'Abrir diagrama em tela cheia' na aplicação.</a:t>
-            </a:r>
-          </a:p>
-        </p:txBody>
-      </p:sp>
-      <p:sp>
-        <p:nvSpPr>
-          <p:cNvPr id="4" name="Slide Number Placeholder 3"/>
-          <p:cNvSpPr>
-            <a:spLocks noGrp="1"/>
-          </p:cNvSpPr>
-          <p:nvPr>
-            <p:ph type="sldNum" idx="5" sz="quarter"/>
-          </p:nvPr>
-        </p:nvSpPr>
-        <p:spPr/>
-      </p:sp>
-    </p:spTree>
-  </p:cSld>
-  <p:clrMapOvr>
-    <a:masterClrMapping/>
-  </p:clrMapOvr>
-</p:notes>
-</file>
-
-<file path=ppt/notesSlides/notesSlide8.xml><?xml version="1.0" encoding="utf-8"?>
-<p:notes xmlns:a="http://schemas.openxmlformats.org/drawingml/2006/main" xmlns:p="http://schemas.openxmlformats.org/presentationml/2006/main" xmlns:r="http://schemas.openxmlformats.org/officeDocument/2006/relationships">
-  <p:cSld>
-    <p:spTree>
-      <p:nvGrpSpPr>
-        <p:cNvPr id="1" name=""/>
-        <p:cNvGrpSpPr/>
-        <p:nvPr/>
-      </p:nvGrpSpPr>
-      <p:grpSpPr>
-        <a:xfrm>
-          <a:off x="0" y="0"/>
-          <a:ext cx="0" cy="0"/>
-          <a:chOff x="0" y="0"/>
-          <a:chExt cx="0" cy="0"/>
-        </a:xfrm>
-      </p:grpSpPr>
-      <p:sp>
-        <p:nvSpPr>
-          <p:cNvPr id="2" name="Slide Image Placeholder 1"/>
-          <p:cNvSpPr>
-            <a:spLocks noGrp="1"/>
-          </p:cNvSpPr>
-          <p:nvPr>
-            <p:ph type="sldImg" idx="2"/>
-          </p:nvPr>
-        </p:nvSpPr>
-        <p:spPr/>
-      </p:sp>
-      <p:sp>
-        <p:nvSpPr>
-          <p:cNvPr id="3" name="Notes Placeholder 2"/>
-          <p:cNvSpPr>
-            <a:spLocks noGrp="1"/>
-          </p:cNvSpPr>
-          <p:nvPr>
-            <p:ph type="body" idx="3" sz="quarter"/>
-          </p:nvPr>
-        </p:nvSpPr>
-        <p:spPr/>
-        <p:txBody>
-          <a:bodyPr/>
-          <a:lstStyle/>
-          <a:p>
-            <a:r>
-              <a:t>PEDRO: Ler a finalidade: Validar a placa do caminhão que fará a coleta. Aceita o padrão antigo brasileiro (LLL-NNNN, com hífen opcional) e o padrão Mercosul (LLLNLNN). Mostrar que cada atalho da sintaxe do código corresponde a um operador formal (tabela de equivalência). re.fullmatch exige que a cadeia inteira pertença à linguagem, como as âncoras ^ e $.</a:t>
-            </a:r>
-          </a:p>
-        </p:txBody>
-      </p:sp>
-      <p:sp>
-        <p:nvSpPr>
-          <p:cNvPr id="4" name="Slide Number Placeholder 3"/>
-          <p:cNvSpPr>
-            <a:spLocks noGrp="1"/>
-          </p:cNvSpPr>
-          <p:nvPr>
-            <p:ph type="sldNum" idx="5" sz="quarter"/>
-          </p:nvPr>
-        </p:nvSpPr>
-        <p:spPr/>
-      </p:sp>
-    </p:spTree>
-  </p:cSld>
-  <p:clrMapOvr>
-    <a:masterClrMapping/>
-  </p:clrMapOvr>
-</p:notes>
-</file>
-
-<file path=ppt/notesSlides/notesSlide9.xml><?xml version="1.0" encoding="utf-8"?>
-<p:notes xmlns:a="http://schemas.openxmlformats.org/drawingml/2006/main" xmlns:p="http://schemas.openxmlformats.org/presentationml/2006/main" xmlns:r="http://schemas.openxmlformats.org/officeDocument/2006/relationships">
-  <p:cSld>
-    <p:spTree>
-      <p:nvGrpSpPr>
-        <p:cNvPr id="1" name=""/>
-        <p:cNvGrpSpPr/>
-        <p:nvPr/>
-      </p:nvGrpSpPr>
-      <p:grpSpPr>
-        <a:xfrm>
-          <a:off x="0" y="0"/>
-          <a:ext cx="0" cy="0"/>
-          <a:chOff x="0" y="0"/>
-          <a:chExt cx="0" cy="0"/>
-        </a:xfrm>
-      </p:grpSpPr>
-      <p:sp>
-        <p:nvSpPr>
-          <p:cNvPr id="2" name="Slide Image Placeholder 1"/>
-          <p:cNvSpPr>
-            <a:spLocks noGrp="1"/>
-          </p:cNvSpPr>
-          <p:nvPr>
-            <p:ph type="sldImg" idx="2"/>
-          </p:nvPr>
-        </p:nvSpPr>
-        <p:spPr/>
-      </p:sp>
-      <p:sp>
-        <p:nvSpPr>
-          <p:cNvPr id="3" name="Notes Placeholder 2"/>
-          <p:cNvSpPr>
-            <a:spLocks noGrp="1"/>
-          </p:cNvSpPr>
-          <p:nvPr>
-            <p:ph type="body" idx="3" sz="quarter"/>
-          </p:nvPr>
-        </p:nvSpPr>
-        <p:spPr/>
-        <p:txBody>
-          <a:bodyPr/>
-          <a:lstStyle/>
-          <a:p>
-            <a:r>
-              <a:t>PEDRO: Mostrar o estado inicial (seta 'início'), o final (círculo duplo) e os movimentos ε (tracejados). Percorrer uma cadeia aceita e uma rejeitada. Para ampliar o diagrama, abrir Expressões e AFNε &gt; ER-02 &gt; 'Abrir diagrama em tela cheia' na aplicação.</a:t>
-            </a:r>
-          </a:p>
-        </p:txBody>
-      </p:sp>
-      <p:sp>
-        <p:nvSpPr>
-          <p:cNvPr id="4" name="Slide Number Placeholder 3"/>
-          <p:cNvSpPr>
-            <a:spLocks noGrp="1"/>
-          </p:cNvSpPr>
-          <p:nvPr>
-            <p:ph type="sldNum" idx="5" sz="quarter"/>
-          </p:nvPr>
-        </p:nvSpPr>
-        <p:spPr/>
-      </p:sp>
-    </p:spTree>
-  </p:cSld>
-  <p:clrMapOvr>
-    <a:masterClrMapping/>
-  </p:clrMapOvr>
-</p:notes>
 </file>
 
 <file path=ppt/slideLayouts/slideLayout1.xml><?xml version="1.0" encoding="utf-8"?>
@@ -27418,324 +25528,4 @@
   </a:objectDefaults>
   <a:extraClrSchemeLst/>
 </a:theme>
-</file>
-
-<file path=ppt/theme/theme2.xml><?xml version="1.0" encoding="utf-8"?>
-<a:theme xmlns:a="http://schemas.openxmlformats.org/drawingml/2006/main" name="Office Theme">
-  <a:themeElements>
-    <a:clrScheme name="Office">
-      <a:dk1>
-        <a:sysClr val="windowText" lastClr="000000"/>
-      </a:dk1>
-      <a:lt1>
-        <a:sysClr val="window" lastClr="FFFFFF"/>
-      </a:lt1>
-      <a:dk2>
-        <a:srgbClr val="1F497D"/>
-      </a:dk2>
-      <a:lt2>
-        <a:srgbClr val="EEECE1"/>
-      </a:lt2>
-      <a:accent1>
-        <a:srgbClr val="4F81BD"/>
-      </a:accent1>
-      <a:accent2>
-        <a:srgbClr val="C0504D"/>
-      </a:accent2>
-      <a:accent3>
-        <a:srgbClr val="9BBB59"/>
-      </a:accent3>
-      <a:accent4>
-        <a:srgbClr val="8064A2"/>
-      </a:accent4>
-      <a:accent5>
-        <a:srgbClr val="4BACC6"/>
-      </a:accent5>
-      <a:accent6>
-        <a:srgbClr val="F79646"/>
-      </a:accent6>
-      <a:hlink>
-        <a:srgbClr val="0000FF"/>
-      </a:hlink>
-      <a:folHlink>
-        <a:srgbClr val="800080"/>
-      </a:folHlink>
-    </a:clrScheme>
-    <a:fontScheme name="Office">
-      <a:majorFont>
-        <a:latin typeface="Calibri"/>
-        <a:ea typeface=""/>
-        <a:cs typeface=""/>
-        <a:font script="Jpan" typeface="ＭＳ Ｐゴシック"/>
-        <a:font script="Hang" typeface="맑은 고딕"/>
-        <a:font script="Hans" typeface="宋体"/>
-        <a:font script="Hant" typeface="新細明體"/>
-        <a:font script="Arab" typeface="Times New Roman"/>
-        <a:font script="Hebr" typeface="Times New Roman"/>
-        <a:font script="Thai" typeface="Angsana New"/>
-        <a:font script="Ethi" typeface="Nyala"/>
-        <a:font script="Beng" typeface="Vrinda"/>
-        <a:font script="Gujr" typeface="Shruti"/>
-        <a:font script="Khmr" typeface="MoolBoran"/>
-        <a:font script="Knda" typeface="Tunga"/>
-        <a:font script="Guru" typeface="Raavi"/>
-        <a:font script="Cans" typeface="Euphemia"/>
-        <a:font script="Cher" typeface="Plantagenet Cherokee"/>
-        <a:font script="Yiii" typeface="Microsoft Yi Baiti"/>
-        <a:font script="Tibt" typeface="Microsoft Himalaya"/>
-        <a:font script="Thaa" typeface="MV Boli"/>
-        <a:font script="Deva" typeface="Mangal"/>
-        <a:font script="Telu" typeface="Gautami"/>
-        <a:font script="Taml" typeface="Latha"/>
-        <a:font script="Syrc" typeface="Estrangelo Edessa"/>
-        <a:font script="Orya" typeface="Kalinga"/>
-        <a:font script="Mlym" typeface="Kartika"/>
-        <a:font script="Laoo" typeface="DokChampa"/>
-        <a:font script="Sinh" typeface="Iskoola Pota"/>
-        <a:font script="Mong" typeface="Mongolian Baiti"/>
-        <a:font script="Viet" typeface="Times New Roman"/>
-        <a:font script="Uigh" typeface="Microsoft Uighur"/>
-        <a:font script="Geor" typeface="Sylfaen"/>
-      </a:majorFont>
-      <a:minorFont>
-        <a:latin typeface="Calibri"/>
-        <a:ea typeface=""/>
-        <a:cs typeface=""/>
-        <a:font script="Jpan" typeface="ＭＳ Ｐゴシック"/>
-        <a:font script="Hang" typeface="맑은 고딕"/>
-        <a:font script="Hans" typeface="宋体"/>
-        <a:font script="Hant" typeface="新細明體"/>
-        <a:font script="Arab" typeface="Arial"/>
-        <a:font script="Hebr" typeface="Arial"/>
-        <a:font script="Thai" typeface="Cordia New"/>
-        <a:font script="Ethi" typeface="Nyala"/>
-        <a:font script="Beng" typeface="Vrinda"/>
-        <a:font script="Gujr" typeface="Shruti"/>
-        <a:font script="Khmr" typeface="DaunPenh"/>
-        <a:font script="Knda" typeface="Tunga"/>
-        <a:font script="Guru" typeface="Raavi"/>
-        <a:font script="Cans" typeface="Euphemia"/>
-        <a:font script="Cher" typeface="Plantagenet Cherokee"/>
-        <a:font script="Yiii" typeface="Microsoft Yi Baiti"/>
-        <a:font script="Tibt" typeface="Microsoft Himalaya"/>
-        <a:font script="Thaa" typeface="MV Boli"/>
-        <a:font script="Deva" typeface="Mangal"/>
-        <a:font script="Telu" typeface="Gautami"/>
-        <a:font script="Taml" typeface="Latha"/>
-        <a:font script="Syrc" typeface="Estrangelo Edessa"/>
-        <a:font script="Orya" typeface="Kalinga"/>
-        <a:font script="Mlym" typeface="Kartika"/>
-        <a:font script="Laoo" typeface="DokChampa"/>
-        <a:font script="Sinh" typeface="Iskoola Pota"/>
-        <a:font script="Mong" typeface="Mongolian Baiti"/>
-        <a:font script="Viet" typeface="Arial"/>
-        <a:font script="Uigh" typeface="Microsoft Uighur"/>
-        <a:font script="Geor" typeface="Sylfaen"/>
-      </a:minorFont>
-    </a:fontScheme>
-    <a:fmtScheme name="Office">
-      <a:fillStyleLst>
-        <a:solidFill>
-          <a:schemeClr val="phClr"/>
-        </a:solidFill>
-        <a:gradFill rotWithShape="1">
-          <a:gsLst>
-            <a:gs pos="0">
-              <a:schemeClr val="phClr">
-                <a:tint val="50000"/>
-                <a:satMod val="300000"/>
-              </a:schemeClr>
-            </a:gs>
-            <a:gs pos="35000">
-              <a:schemeClr val="phClr">
-                <a:tint val="37000"/>
-                <a:satMod val="300000"/>
-              </a:schemeClr>
-            </a:gs>
-            <a:gs pos="100000">
-              <a:schemeClr val="phClr">
-                <a:tint val="15000"/>
-                <a:satMod val="350000"/>
-              </a:schemeClr>
-            </a:gs>
-          </a:gsLst>
-          <a:lin ang="16200000" scaled="1"/>
-        </a:gradFill>
-        <a:gradFill rotWithShape="1">
-          <a:gsLst>
-            <a:gs pos="0">
-              <a:schemeClr val="phClr">
-                <a:tint val="100000"/>
-                <a:shade val="100000"/>
-                <a:satMod val="130000"/>
-              </a:schemeClr>
-            </a:gs>
-            <a:gs pos="100000">
-              <a:schemeClr val="phClr">
-                <a:tint val="50000"/>
-                <a:shade val="100000"/>
-                <a:satMod val="350000"/>
-              </a:schemeClr>
-            </a:gs>
-          </a:gsLst>
-          <a:lin ang="16200000" scaled="0"/>
-        </a:gradFill>
-      </a:fillStyleLst>
-      <a:lnStyleLst>
-        <a:ln w="9525" cap="flat" cmpd="sng" algn="ctr">
-          <a:solidFill>
-            <a:schemeClr val="phClr">
-              <a:shade val="95000"/>
-              <a:satMod val="105000"/>
-            </a:schemeClr>
-          </a:solidFill>
-          <a:prstDash val="solid"/>
-        </a:ln>
-        <a:ln w="25400" cap="flat" cmpd="sng" algn="ctr">
-          <a:solidFill>
-            <a:schemeClr val="phClr"/>
-          </a:solidFill>
-          <a:prstDash val="solid"/>
-        </a:ln>
-        <a:ln w="38100" cap="flat" cmpd="sng" algn="ctr">
-          <a:solidFill>
-            <a:schemeClr val="phClr"/>
-          </a:solidFill>
-          <a:prstDash val="solid"/>
-        </a:ln>
-      </a:lnStyleLst>
-      <a:effectStyleLst>
-        <a:effectStyle>
-          <a:effectLst>
-            <a:outerShdw blurRad="40000" dist="20000" dir="5400000" rotWithShape="0">
-              <a:srgbClr val="000000">
-                <a:alpha val="38000"/>
-              </a:srgbClr>
-            </a:outerShdw>
-          </a:effectLst>
-        </a:effectStyle>
-        <a:effectStyle>
-          <a:effectLst>
-            <a:outerShdw blurRad="40000" dist="23000" dir="5400000" rotWithShape="0">
-              <a:srgbClr val="000000">
-                <a:alpha val="35000"/>
-              </a:srgbClr>
-            </a:outerShdw>
-          </a:effectLst>
-        </a:effectStyle>
-        <a:effectStyle>
-          <a:effectLst>
-            <a:outerShdw blurRad="40000" dist="23000" dir="5400000" rotWithShape="0">
-              <a:srgbClr val="000000">
-                <a:alpha val="35000"/>
-              </a:srgbClr>
-            </a:outerShdw>
-          </a:effectLst>
-          <a:scene3d>
-            <a:camera prst="orthographicFront">
-              <a:rot lat="0" lon="0" rev="0"/>
-            </a:camera>
-            <a:lightRig rig="threePt" dir="t">
-              <a:rot lat="0" lon="0" rev="1200000"/>
-            </a:lightRig>
-          </a:scene3d>
-          <a:sp3d>
-            <a:bevelT w="63500" h="25400"/>
-          </a:sp3d>
-        </a:effectStyle>
-      </a:effectStyleLst>
-      <a:bgFillStyleLst>
-        <a:solidFill>
-          <a:schemeClr val="phClr"/>
-        </a:solidFill>
-        <a:gradFill rotWithShape="1">
-          <a:gsLst>
-            <a:gs pos="0">
-              <a:schemeClr val="phClr">
-                <a:tint val="40000"/>
-                <a:satMod val="350000"/>
-              </a:schemeClr>
-            </a:gs>
-            <a:gs pos="40000">
-              <a:schemeClr val="phClr">
-                <a:tint val="45000"/>
-                <a:shade val="99000"/>
-                <a:satMod val="350000"/>
-              </a:schemeClr>
-            </a:gs>
-            <a:gs pos="100000">
-              <a:schemeClr val="phClr">
-                <a:shade val="20000"/>
-                <a:satMod val="255000"/>
-              </a:schemeClr>
-            </a:gs>
-          </a:gsLst>
-          <a:path path="circle">
-            <a:fillToRect l="50000" t="-80000" r="50000" b="180000"/>
-          </a:path>
-        </a:gradFill>
-        <a:gradFill rotWithShape="1">
-          <a:gsLst>
-            <a:gs pos="0">
-              <a:schemeClr val="phClr">
-                <a:tint val="80000"/>
-                <a:satMod val="300000"/>
-              </a:schemeClr>
-            </a:gs>
-            <a:gs pos="100000">
-              <a:schemeClr val="phClr">
-                <a:shade val="30000"/>
-                <a:satMod val="200000"/>
-              </a:schemeClr>
-            </a:gs>
-          </a:gsLst>
-          <a:path path="circle">
-            <a:fillToRect l="50000" t="50000" r="50000" b="50000"/>
-          </a:path>
-        </a:gradFill>
-      </a:bgFillStyleLst>
-    </a:fmtScheme>
-  </a:themeElements>
-  <a:objectDefaults>
-    <a:spDef>
-      <a:spPr/>
-      <a:bodyPr/>
-      <a:lstStyle/>
-      <a:style>
-        <a:lnRef idx="1">
-          <a:schemeClr val="accent1"/>
-        </a:lnRef>
-        <a:fillRef idx="3">
-          <a:schemeClr val="accent1"/>
-        </a:fillRef>
-        <a:effectRef idx="2">
-          <a:schemeClr val="accent1"/>
-        </a:effectRef>
-        <a:fontRef idx="minor">
-          <a:schemeClr val="lt1"/>
-        </a:fontRef>
-      </a:style>
-    </a:spDef>
-    <a:lnDef>
-      <a:spPr/>
-      <a:bodyPr/>
-      <a:lstStyle/>
-      <a:style>
-        <a:lnRef idx="2">
-          <a:schemeClr val="accent1"/>
-        </a:lnRef>
-        <a:fillRef idx="0">
-          <a:schemeClr val="accent1"/>
-        </a:fillRef>
-        <a:effectRef idx="1">
-          <a:schemeClr val="accent1"/>
-        </a:effectRef>
-        <a:fontRef idx="minor">
-          <a:schemeClr val="tx1"/>
-        </a:fontRef>
-      </a:style>
-    </a:lnDef>
-  </a:objectDefaults>
-  <a:extraClrSchemeLst/>
-</a:theme>
 </file>
</xml_diff>

<commit_message>
Remove a divisão de falas do slide de contribuições
</commit_message>
<xml_diff>
--- a/docs/entrega/apresentacao.pptx
+++ b/docs/entrega/apresentacao.pptx
@@ -16053,7 +16053,7 @@
         <p:spPr>
           <a:xfrm>
             <a:off x="548640" y="1463040"/>
-            <a:ext cx="3520440" cy="3017520"/>
+            <a:ext cx="3520440" cy="2834640"/>
           </a:xfrm>
           <a:prstGeom prst="roundRect">
             <a:avLst>
@@ -16214,8 +16214,8 @@
         </p:nvSpPr>
         <p:spPr>
           <a:xfrm>
-            <a:off x="822959" y="2606040"/>
-            <a:ext cx="3017520" cy="1188720"/>
+            <a:off x="822959" y="2651760"/>
+            <a:ext cx="3017520" cy="1463040"/>
           </a:xfrm>
           <a:prstGeom prst="rect">
             <a:avLst/>
@@ -16230,7 +16230,7 @@
           <a:p>
             <a:pPr algn="l"/>
             <a:r>
-              <a:rPr sz="1400" b="0" i="0">
+              <a:rPr sz="1500" b="0" i="0">
                 <a:solidFill>
                   <a:srgbClr val="1F2933"/>
                 </a:solidFill>
@@ -16243,49 +16243,14 @@
       </p:sp>
       <p:sp>
         <p:nvSpPr>
-          <p:cNvPr id="8" name="TextBox 7"/>
-          <p:cNvSpPr txBox="1"/>
-          <p:nvPr/>
-        </p:nvSpPr>
-        <p:spPr>
-          <a:xfrm>
-            <a:off x="822959" y="3840480"/>
-            <a:ext cx="3017520" cy="457200"/>
-          </a:xfrm>
-          <a:prstGeom prst="rect">
-            <a:avLst/>
-          </a:prstGeom>
-          <a:noFill/>
-        </p:spPr>
-        <p:txBody>
-          <a:bodyPr wrap="square" anchor="t" lIns="0" rIns="0" tIns="0" bIns="0">
-            <a:spAutoFit/>
-          </a:bodyPr>
-          <a:lstStyle/>
-          <a:p>
-            <a:pPr algn="l"/>
-            <a:r>
-              <a:rPr sz="1300" b="1" i="0">
-                <a:solidFill>
-                  <a:srgbClr val="5B6B7F"/>
-                </a:solidFill>
-                <a:latin typeface="Calibri"/>
-              </a:rPr>
-              <a:t>Thompson · ER-03 · demonstração</a:t>
-            </a:r>
-          </a:p>
-        </p:txBody>
-      </p:sp>
-      <p:sp>
-        <p:nvSpPr>
-          <p:cNvPr id="9" name="Rounded Rectangle 8"/>
+          <p:cNvPr id="8" name="Rounded Rectangle 7"/>
           <p:cNvSpPr/>
           <p:nvPr/>
         </p:nvSpPr>
         <p:spPr>
           <a:xfrm>
             <a:off x="4297679" y="1463040"/>
-            <a:ext cx="3520440" cy="3017520"/>
+            <a:ext cx="3520440" cy="2834640"/>
           </a:xfrm>
           <a:prstGeom prst="roundRect">
             <a:avLst>
@@ -16324,7 +16289,7 @@
       </p:sp>
       <p:sp>
         <p:nvSpPr>
-          <p:cNvPr id="10" name="Rounded Rectangle 9"/>
+          <p:cNvPr id="9" name="Rounded Rectangle 8"/>
           <p:cNvSpPr/>
           <p:nvPr/>
         </p:nvSpPr>
@@ -16370,7 +16335,7 @@
       </p:sp>
       <p:sp>
         <p:nvSpPr>
-          <p:cNvPr id="11" name="TextBox 10"/>
+          <p:cNvPr id="10" name="TextBox 9"/>
           <p:cNvSpPr txBox="1"/>
           <p:nvPr/>
         </p:nvSpPr>
@@ -16405,7 +16370,7 @@
       </p:sp>
       <p:sp>
         <p:nvSpPr>
-          <p:cNvPr id="12" name="TextBox 11"/>
+          <p:cNvPr id="11" name="TextBox 10"/>
           <p:cNvSpPr txBox="1"/>
           <p:nvPr/>
         </p:nvSpPr>
@@ -16440,14 +16405,14 @@
       </p:sp>
       <p:sp>
         <p:nvSpPr>
-          <p:cNvPr id="13" name="TextBox 12"/>
-          <p:cNvSpPr txBox="1"/>
-          <p:nvPr/>
-        </p:nvSpPr>
-        <p:spPr>
-          <a:xfrm>
-            <a:off x="4571999" y="2606040"/>
-            <a:ext cx="3017520" cy="1188720"/>
+          <p:cNvPr id="12" name="TextBox 11"/>
+          <p:cNvSpPr txBox="1"/>
+          <p:nvPr/>
+        </p:nvSpPr>
+        <p:spPr>
+          <a:xfrm>
+            <a:off x="4571999" y="2651760"/>
+            <a:ext cx="3017520" cy="1463040"/>
           </a:xfrm>
           <a:prstGeom prst="rect">
             <a:avLst/>
@@ -16462,7 +16427,7 @@
           <a:p>
             <a:pPr algn="l"/>
             <a:r>
-              <a:rPr sz="1400" b="0" i="0">
+              <a:rPr sz="1500" b="0" i="0">
                 <a:solidFill>
                   <a:srgbClr val="1F2933"/>
                 </a:solidFill>
@@ -16475,49 +16440,14 @@
       </p:sp>
       <p:sp>
         <p:nvSpPr>
-          <p:cNvPr id="14" name="TextBox 13"/>
-          <p:cNvSpPr txBox="1"/>
-          <p:nvPr/>
-        </p:nvSpPr>
-        <p:spPr>
-          <a:xfrm>
-            <a:off x="4571999" y="3840480"/>
-            <a:ext cx="3017520" cy="457200"/>
-          </a:xfrm>
-          <a:prstGeom prst="rect">
-            <a:avLst/>
-          </a:prstGeom>
-          <a:noFill/>
-        </p:spPr>
-        <p:txBody>
-          <a:bodyPr wrap="square" anchor="t" lIns="0" rIns="0" tIns="0" bIns="0">
-            <a:spAutoFit/>
-          </a:bodyPr>
-          <a:lstStyle/>
-          <a:p>
-            <a:pPr algn="l"/>
-            <a:r>
-              <a:rPr sz="1300" b="1" i="0">
-                <a:solidFill>
-                  <a:srgbClr val="5B6B7F"/>
-                </a:solidFill>
-                <a:latin typeface="Calibri"/>
-              </a:rPr>
-              <a:t>ER-01 · ER-02</a:t>
-            </a:r>
-          </a:p>
-        </p:txBody>
-      </p:sp>
-      <p:sp>
-        <p:nvSpPr>
-          <p:cNvPr id="15" name="Rounded Rectangle 14"/>
+          <p:cNvPr id="13" name="Rounded Rectangle 12"/>
           <p:cNvSpPr/>
           <p:nvPr/>
         </p:nvSpPr>
         <p:spPr>
           <a:xfrm>
             <a:off x="8046719" y="1463040"/>
-            <a:ext cx="3520440" cy="3017520"/>
+            <a:ext cx="3520440" cy="2834640"/>
           </a:xfrm>
           <a:prstGeom prst="roundRect">
             <a:avLst>
@@ -16556,7 +16486,7 @@
       </p:sp>
       <p:sp>
         <p:nvSpPr>
-          <p:cNvPr id="16" name="Rounded Rectangle 15"/>
+          <p:cNvPr id="14" name="Rounded Rectangle 13"/>
           <p:cNvSpPr/>
           <p:nvPr/>
         </p:nvSpPr>
@@ -16602,7 +16532,7 @@
       </p:sp>
       <p:sp>
         <p:nvSpPr>
-          <p:cNvPr id="17" name="TextBox 16"/>
+          <p:cNvPr id="15" name="TextBox 14"/>
           <p:cNvSpPr txBox="1"/>
           <p:nvPr/>
         </p:nvSpPr>
@@ -16637,7 +16567,7 @@
       </p:sp>
       <p:sp>
         <p:nvSpPr>
-          <p:cNvPr id="18" name="TextBox 17"/>
+          <p:cNvPr id="16" name="TextBox 15"/>
           <p:cNvSpPr txBox="1"/>
           <p:nvPr/>
         </p:nvSpPr>
@@ -16672,14 +16602,14 @@
       </p:sp>
       <p:sp>
         <p:nvSpPr>
-          <p:cNvPr id="19" name="TextBox 18"/>
-          <p:cNvSpPr txBox="1"/>
-          <p:nvPr/>
-        </p:nvSpPr>
-        <p:spPr>
-          <a:xfrm>
-            <a:off x="8321040" y="2606040"/>
-            <a:ext cx="3017520" cy="1188720"/>
+          <p:cNvPr id="17" name="TextBox 16"/>
+          <p:cNvSpPr txBox="1"/>
+          <p:nvPr/>
+        </p:nvSpPr>
+        <p:spPr>
+          <a:xfrm>
+            <a:off x="8321040" y="2651760"/>
+            <a:ext cx="3017520" cy="1463040"/>
           </a:xfrm>
           <a:prstGeom prst="rect">
             <a:avLst/>
@@ -16694,7 +16624,7 @@
           <a:p>
             <a:pPr algn="l"/>
             <a:r>
-              <a:rPr sz="1400" b="0" i="0">
+              <a:rPr sz="1500" b="0" i="0">
                 <a:solidFill>
                   <a:srgbClr val="1F2933"/>
                 </a:solidFill>
@@ -16707,48 +16637,13 @@
       </p:sp>
       <p:sp>
         <p:nvSpPr>
-          <p:cNvPr id="20" name="TextBox 19"/>
-          <p:cNvSpPr txBox="1"/>
-          <p:nvPr/>
-        </p:nvSpPr>
-        <p:spPr>
-          <a:xfrm>
-            <a:off x="8321040" y="3840480"/>
-            <a:ext cx="3017520" cy="457200"/>
-          </a:xfrm>
-          <a:prstGeom prst="rect">
-            <a:avLst/>
-          </a:prstGeom>
-          <a:noFill/>
-        </p:spPr>
-        <p:txBody>
-          <a:bodyPr wrap="square" anchor="t" lIns="0" rIns="0" tIns="0" bIns="0">
-            <a:spAutoFit/>
-          </a:bodyPr>
-          <a:lstStyle/>
-          <a:p>
-            <a:pPr algn="l"/>
-            <a:r>
-              <a:rPr sz="1300" b="1" i="0">
-                <a:solidFill>
-                  <a:srgbClr val="5B6B7F"/>
-                </a:solidFill>
-                <a:latin typeface="Calibri"/>
-              </a:rPr>
-              <a:t>ER-04 · ER-05 · testes</a:t>
-            </a:r>
-          </a:p>
-        </p:txBody>
-      </p:sp>
-      <p:sp>
-        <p:nvSpPr>
-          <p:cNvPr id="21" name="Rounded Rectangle 20"/>
+          <p:cNvPr id="18" name="Rounded Rectangle 17"/>
           <p:cNvSpPr/>
           <p:nvPr/>
         </p:nvSpPr>
         <p:spPr>
           <a:xfrm>
-            <a:off x="548640" y="4800600"/>
+            <a:off x="548640" y="4663440"/>
             <a:ext cx="11064240" cy="1143000"/>
           </a:xfrm>
           <a:prstGeom prst="roundRect">
@@ -16788,13 +16683,13 @@
       </p:sp>
       <p:sp>
         <p:nvSpPr>
-          <p:cNvPr id="22" name="TextBox 21"/>
-          <p:cNvSpPr txBox="1"/>
-          <p:nvPr/>
-        </p:nvSpPr>
-        <p:spPr>
-          <a:xfrm>
-            <a:off x="777240" y="4910328"/>
+          <p:cNvPr id="19" name="TextBox 18"/>
+          <p:cNvSpPr txBox="1"/>
+          <p:nvPr/>
+        </p:nvSpPr>
+        <p:spPr>
+          <a:xfrm>
+            <a:off x="777240" y="4773168"/>
             <a:ext cx="10607040" cy="960120"/>
           </a:xfrm>
           <a:prstGeom prst="rect">

</xml_diff>